<commit_message>
chore: complete production readiness remediation audit
</commit_message>
<xml_diff>
--- a/outputs/LMS-Build-Or-Buy.pptx
+++ b/outputs/LMS-Build-Or-Buy.pptx
@@ -942,7 +942,7 @@
           <a:bodyPr/>
           <a:lstStyle/>
           <a:p>
-            <a:endParaRPr/>
+            <a:endParaRPr dirty="0"/>
           </a:p>
         </p:txBody>
       </p:sp>
@@ -5833,8 +5833,8 @@
         </p:nvSpPr>
         <p:spPr>
           <a:xfrm>
-            <a:off x="635000" y="1466850"/>
-            <a:ext cx="2501900" cy="552450"/>
+            <a:off x="635000" y="1417320"/>
+            <a:ext cx="2501900" cy="502920"/>
           </a:xfrm>
           <a:prstGeom prst="rect">
             <a:avLst/>
@@ -5887,7 +5887,7 @@
         </p:nvSpPr>
         <p:spPr>
           <a:xfrm>
-            <a:off x="736600" y="1606550"/>
+            <a:off x="736600" y="1557172"/>
             <a:ext cx="2298700" cy="276999"/>
           </a:xfrm>
           <a:prstGeom prst="rect">
@@ -5927,8 +5927,8 @@
         </p:nvSpPr>
         <p:spPr>
           <a:xfrm>
-            <a:off x="3136900" y="1466850"/>
-            <a:ext cx="2667000" cy="552450"/>
+            <a:off x="3136900" y="1417320"/>
+            <a:ext cx="2667000" cy="502920"/>
           </a:xfrm>
           <a:prstGeom prst="rect">
             <a:avLst/>
@@ -5981,7 +5981,7 @@
         </p:nvSpPr>
         <p:spPr>
           <a:xfrm>
-            <a:off x="3238500" y="1606550"/>
+            <a:off x="3238500" y="1557172"/>
             <a:ext cx="2463800" cy="276999"/>
           </a:xfrm>
           <a:prstGeom prst="rect">
@@ -6002,7 +6002,7 @@
                 </a:solidFill>
                 <a:latin typeface="Aptos" panose="020B0004020202020204" pitchFamily="34" charset="0"/>
               </a:rPr>
-              <a:t>Vendor A: Yubi</a:t>
+              <a:t>Yubi</a:t>
             </a:r>
           </a:p>
         </p:txBody>
@@ -6021,8 +6021,8 @@
         </p:nvSpPr>
         <p:spPr>
           <a:xfrm>
-            <a:off x="5803900" y="1466850"/>
-            <a:ext cx="2667000" cy="552450"/>
+            <a:off x="5803900" y="1417320"/>
+            <a:ext cx="2667000" cy="502920"/>
           </a:xfrm>
           <a:prstGeom prst="rect">
             <a:avLst/>
@@ -6075,7 +6075,7 @@
         </p:nvSpPr>
         <p:spPr>
           <a:xfrm>
-            <a:off x="5905500" y="1606550"/>
+            <a:off x="5905500" y="1557172"/>
             <a:ext cx="2463800" cy="276999"/>
           </a:xfrm>
           <a:prstGeom prst="rect">
@@ -6096,7 +6096,7 @@
                 </a:solidFill>
                 <a:latin typeface="Aptos" panose="020B0004020202020204" pitchFamily="34" charset="0"/>
               </a:rPr>
-              <a:t>Vendor B: M2P</a:t>
+              <a:t>M2P Fintech</a:t>
             </a:r>
           </a:p>
         </p:txBody>
@@ -6115,8 +6115,8 @@
         </p:nvSpPr>
         <p:spPr>
           <a:xfrm>
-            <a:off x="8470900" y="1466850"/>
-            <a:ext cx="2654300" cy="552450"/>
+            <a:off x="8470900" y="1417320"/>
+            <a:ext cx="2654300" cy="502920"/>
           </a:xfrm>
           <a:prstGeom prst="rect">
             <a:avLst/>
@@ -6169,7 +6169,7 @@
         </p:nvSpPr>
         <p:spPr>
           <a:xfrm>
-            <a:off x="8572500" y="1606550"/>
+            <a:off x="8572500" y="1557172"/>
             <a:ext cx="2451100" cy="276999"/>
           </a:xfrm>
           <a:prstGeom prst="rect">
@@ -6209,8 +6209,8 @@
         </p:nvSpPr>
         <p:spPr>
           <a:xfrm>
-            <a:off x="635000" y="2019300"/>
-            <a:ext cx="2501900" cy="609600"/>
+            <a:off x="635000" y="1920240"/>
+            <a:ext cx="2501900" cy="566928"/>
           </a:xfrm>
           <a:prstGeom prst="rect">
             <a:avLst/>
@@ -6263,7 +6263,7 @@
         </p:nvSpPr>
         <p:spPr>
           <a:xfrm>
-            <a:off x="736600" y="2159000"/>
+            <a:off x="736600" y="2060244"/>
             <a:ext cx="2298700" cy="276999"/>
           </a:xfrm>
           <a:prstGeom prst="rect">
@@ -6303,8 +6303,8 @@
         </p:nvSpPr>
         <p:spPr>
           <a:xfrm>
-            <a:off x="3136900" y="2019300"/>
-            <a:ext cx="2667000" cy="609600"/>
+            <a:off x="3136900" y="1920240"/>
+            <a:ext cx="2667000" cy="566928"/>
           </a:xfrm>
           <a:prstGeom prst="rect">
             <a:avLst/>
@@ -6357,7 +6357,7 @@
         </p:nvSpPr>
         <p:spPr>
           <a:xfrm>
-            <a:off x="3238500" y="2159000"/>
+            <a:off x="3238500" y="2060244"/>
             <a:ext cx="2463800" cy="276999"/>
           </a:xfrm>
           <a:prstGeom prst="rect">
@@ -6408,8 +6408,8 @@
         </p:nvSpPr>
         <p:spPr>
           <a:xfrm>
-            <a:off x="5803900" y="2019300"/>
-            <a:ext cx="2667000" cy="609600"/>
+            <a:off x="5803900" y="1920240"/>
+            <a:ext cx="2667000" cy="566928"/>
           </a:xfrm>
           <a:prstGeom prst="rect">
             <a:avLst/>
@@ -6462,7 +6462,7 @@
         </p:nvSpPr>
         <p:spPr>
           <a:xfrm>
-            <a:off x="5905500" y="2159000"/>
+            <a:off x="5905500" y="2060244"/>
             <a:ext cx="2463800" cy="276999"/>
           </a:xfrm>
           <a:prstGeom prst="rect">
@@ -6513,8 +6513,8 @@
         </p:nvSpPr>
         <p:spPr>
           <a:xfrm>
-            <a:off x="8470900" y="2019300"/>
-            <a:ext cx="2654300" cy="609600"/>
+            <a:off x="8470900" y="1920240"/>
+            <a:ext cx="2654300" cy="566928"/>
           </a:xfrm>
           <a:prstGeom prst="rect">
             <a:avLst/>
@@ -6567,7 +6567,7 @@
         </p:nvSpPr>
         <p:spPr>
           <a:xfrm>
-            <a:off x="8572500" y="2159000"/>
+            <a:off x="8572500" y="2060244"/>
             <a:ext cx="2451100" cy="276999"/>
           </a:xfrm>
           <a:prstGeom prst="rect">
@@ -6607,8 +6607,8 @@
         </p:nvSpPr>
         <p:spPr>
           <a:xfrm>
-            <a:off x="635000" y="2628900"/>
-            <a:ext cx="2501900" cy="660400"/>
+            <a:off x="635000" y="2487168"/>
+            <a:ext cx="2501900" cy="566928"/>
           </a:xfrm>
           <a:prstGeom prst="rect">
             <a:avLst/>
@@ -6661,7 +6661,7 @@
         </p:nvSpPr>
         <p:spPr>
           <a:xfrm>
-            <a:off x="736600" y="2768600"/>
+            <a:off x="736600" y="2626868"/>
             <a:ext cx="2298700" cy="276999"/>
           </a:xfrm>
           <a:prstGeom prst="rect">
@@ -6701,8 +6701,8 @@
         </p:nvSpPr>
         <p:spPr>
           <a:xfrm>
-            <a:off x="3136900" y="2628900"/>
-            <a:ext cx="2667000" cy="660400"/>
+            <a:off x="3136900" y="2487168"/>
+            <a:ext cx="2667000" cy="566928"/>
           </a:xfrm>
           <a:prstGeom prst="rect">
             <a:avLst/>
@@ -6755,7 +6755,7 @@
         </p:nvSpPr>
         <p:spPr>
           <a:xfrm>
-            <a:off x="3238500" y="2768600"/>
+            <a:off x="3238500" y="2626868"/>
             <a:ext cx="2463800" cy="276999"/>
           </a:xfrm>
           <a:prstGeom prst="rect">
@@ -6795,8 +6795,8 @@
         </p:nvSpPr>
         <p:spPr>
           <a:xfrm>
-            <a:off x="5803900" y="2628900"/>
-            <a:ext cx="2667000" cy="660400"/>
+            <a:off x="5803900" y="2487168"/>
+            <a:ext cx="2667000" cy="566928"/>
           </a:xfrm>
           <a:prstGeom prst="rect">
             <a:avLst/>
@@ -6849,7 +6849,7 @@
         </p:nvSpPr>
         <p:spPr>
           <a:xfrm>
-            <a:off x="5905500" y="2768600"/>
+            <a:off x="5905500" y="2626868"/>
             <a:ext cx="2463800" cy="276999"/>
           </a:xfrm>
           <a:prstGeom prst="rect">
@@ -6889,8 +6889,8 @@
         </p:nvSpPr>
         <p:spPr>
           <a:xfrm>
-            <a:off x="8470900" y="2628900"/>
-            <a:ext cx="2654300" cy="660400"/>
+            <a:off x="8470900" y="2487168"/>
+            <a:ext cx="2654300" cy="566928"/>
           </a:xfrm>
           <a:prstGeom prst="rect">
             <a:avLst/>
@@ -6943,7 +6943,7 @@
         </p:nvSpPr>
         <p:spPr>
           <a:xfrm>
-            <a:off x="8572500" y="2768600"/>
+            <a:off x="8572500" y="2626868"/>
             <a:ext cx="2451100" cy="276999"/>
           </a:xfrm>
           <a:prstGeom prst="rect">
@@ -6983,8 +6983,8 @@
         </p:nvSpPr>
         <p:spPr>
           <a:xfrm>
-            <a:off x="635000" y="3289300"/>
-            <a:ext cx="2501900" cy="584200"/>
+            <a:off x="635000" y="3054096"/>
+            <a:ext cx="2501900" cy="566928"/>
           </a:xfrm>
           <a:prstGeom prst="rect">
             <a:avLst/>
@@ -7037,7 +7037,7 @@
         </p:nvSpPr>
         <p:spPr>
           <a:xfrm>
-            <a:off x="736600" y="3429000"/>
+            <a:off x="736600" y="3193999"/>
             <a:ext cx="2298700" cy="276999"/>
           </a:xfrm>
           <a:prstGeom prst="rect">
@@ -7077,8 +7077,8 @@
         </p:nvSpPr>
         <p:spPr>
           <a:xfrm>
-            <a:off x="3136900" y="3289300"/>
-            <a:ext cx="2667000" cy="584200"/>
+            <a:off x="3136900" y="3054096"/>
+            <a:ext cx="2667000" cy="566928"/>
           </a:xfrm>
           <a:prstGeom prst="rect">
             <a:avLst/>
@@ -7131,7 +7131,7 @@
         </p:nvSpPr>
         <p:spPr>
           <a:xfrm>
-            <a:off x="3238500" y="3429000"/>
+            <a:off x="3238500" y="3193999"/>
             <a:ext cx="2463800" cy="276999"/>
           </a:xfrm>
           <a:prstGeom prst="rect">
@@ -7171,8 +7171,8 @@
         </p:nvSpPr>
         <p:spPr>
           <a:xfrm>
-            <a:off x="5803900" y="3289300"/>
-            <a:ext cx="2667000" cy="584200"/>
+            <a:off x="5803900" y="3054096"/>
+            <a:ext cx="2667000" cy="566928"/>
           </a:xfrm>
           <a:prstGeom prst="rect">
             <a:avLst/>
@@ -7225,7 +7225,7 @@
         </p:nvSpPr>
         <p:spPr>
           <a:xfrm>
-            <a:off x="5905500" y="3429000"/>
+            <a:off x="5905500" y="3193999"/>
             <a:ext cx="2463800" cy="276999"/>
           </a:xfrm>
           <a:prstGeom prst="rect">
@@ -7265,8 +7265,8 @@
         </p:nvSpPr>
         <p:spPr>
           <a:xfrm>
-            <a:off x="8470900" y="3289300"/>
-            <a:ext cx="2654300" cy="584200"/>
+            <a:off x="8470900" y="3054096"/>
+            <a:ext cx="2654300" cy="566928"/>
           </a:xfrm>
           <a:prstGeom prst="rect">
             <a:avLst/>
@@ -7319,7 +7319,7 @@
         </p:nvSpPr>
         <p:spPr>
           <a:xfrm>
-            <a:off x="8572500" y="3429000"/>
+            <a:off x="8572500" y="3193999"/>
             <a:ext cx="2451100" cy="276999"/>
           </a:xfrm>
           <a:prstGeom prst="rect">
@@ -7359,8 +7359,8 @@
         </p:nvSpPr>
         <p:spPr>
           <a:xfrm>
-            <a:off x="635000" y="3873500"/>
-            <a:ext cx="2501900" cy="584200"/>
+            <a:off x="635000" y="3621024"/>
+            <a:ext cx="2501900" cy="566928"/>
           </a:xfrm>
           <a:prstGeom prst="rect">
             <a:avLst/>
@@ -7413,7 +7413,7 @@
         </p:nvSpPr>
         <p:spPr>
           <a:xfrm>
-            <a:off x="736600" y="4013200"/>
+            <a:off x="736600" y="3760825"/>
             <a:ext cx="2298700" cy="276999"/>
           </a:xfrm>
           <a:prstGeom prst="rect">
@@ -7453,8 +7453,8 @@
         </p:nvSpPr>
         <p:spPr>
           <a:xfrm>
-            <a:off x="3136900" y="3873500"/>
-            <a:ext cx="2667000" cy="584200"/>
+            <a:off x="3136900" y="3621024"/>
+            <a:ext cx="2667000" cy="566928"/>
           </a:xfrm>
           <a:prstGeom prst="rect">
             <a:avLst/>
@@ -7507,7 +7507,7 @@
         </p:nvSpPr>
         <p:spPr>
           <a:xfrm>
-            <a:off x="3238500" y="4013200"/>
+            <a:off x="3238500" y="3760825"/>
             <a:ext cx="2463800" cy="276999"/>
           </a:xfrm>
           <a:prstGeom prst="rect">
@@ -7547,8 +7547,8 @@
         </p:nvSpPr>
         <p:spPr>
           <a:xfrm>
-            <a:off x="5803900" y="3873500"/>
-            <a:ext cx="2667000" cy="584200"/>
+            <a:off x="5803900" y="3621024"/>
+            <a:ext cx="2667000" cy="566928"/>
           </a:xfrm>
           <a:prstGeom prst="rect">
             <a:avLst/>
@@ -7601,7 +7601,7 @@
         </p:nvSpPr>
         <p:spPr>
           <a:xfrm>
-            <a:off x="5905500" y="4013200"/>
+            <a:off x="5905500" y="3760825"/>
             <a:ext cx="2463800" cy="276999"/>
           </a:xfrm>
           <a:prstGeom prst="rect">
@@ -7641,8 +7641,8 @@
         </p:nvSpPr>
         <p:spPr>
           <a:xfrm>
-            <a:off x="8470900" y="3873500"/>
-            <a:ext cx="2654300" cy="584200"/>
+            <a:off x="8470900" y="3621024"/>
+            <a:ext cx="2654300" cy="566928"/>
           </a:xfrm>
           <a:prstGeom prst="rect">
             <a:avLst/>
@@ -7695,7 +7695,7 @@
         </p:nvSpPr>
         <p:spPr>
           <a:xfrm>
-            <a:off x="8572500" y="4013200"/>
+            <a:off x="8572500" y="3760825"/>
             <a:ext cx="2451100" cy="276999"/>
           </a:xfrm>
           <a:prstGeom prst="rect">
@@ -7735,8 +7735,8 @@
         </p:nvSpPr>
         <p:spPr>
           <a:xfrm>
-            <a:off x="635000" y="4457700"/>
-            <a:ext cx="2501900" cy="635000"/>
+            <a:off x="635000" y="4187952"/>
+            <a:ext cx="2501900" cy="566928"/>
           </a:xfrm>
           <a:prstGeom prst="rect">
             <a:avLst/>
@@ -7789,7 +7789,7 @@
         </p:nvSpPr>
         <p:spPr>
           <a:xfrm>
-            <a:off x="736600" y="4597400"/>
+            <a:off x="736600" y="4327652"/>
             <a:ext cx="2298700" cy="276999"/>
           </a:xfrm>
           <a:prstGeom prst="rect">
@@ -7829,8 +7829,8 @@
         </p:nvSpPr>
         <p:spPr>
           <a:xfrm>
-            <a:off x="3136900" y="4457700"/>
-            <a:ext cx="2667000" cy="635000"/>
+            <a:off x="3136900" y="4187952"/>
+            <a:ext cx="2667000" cy="566928"/>
           </a:xfrm>
           <a:prstGeom prst="rect">
             <a:avLst/>
@@ -7883,7 +7883,7 @@
         </p:nvSpPr>
         <p:spPr>
           <a:xfrm>
-            <a:off x="3238500" y="4597400"/>
+            <a:off x="3238500" y="4327652"/>
             <a:ext cx="2463800" cy="276999"/>
           </a:xfrm>
           <a:prstGeom prst="rect">
@@ -7923,8 +7923,8 @@
         </p:nvSpPr>
         <p:spPr>
           <a:xfrm>
-            <a:off x="5803900" y="4457700"/>
-            <a:ext cx="2667000" cy="635000"/>
+            <a:off x="5803900" y="4187952"/>
+            <a:ext cx="2667000" cy="566928"/>
           </a:xfrm>
           <a:prstGeom prst="rect">
             <a:avLst/>
@@ -7977,7 +7977,7 @@
         </p:nvSpPr>
         <p:spPr>
           <a:xfrm>
-            <a:off x="5905500" y="4597400"/>
+            <a:off x="5905500" y="4327652"/>
             <a:ext cx="2463800" cy="276999"/>
           </a:xfrm>
           <a:prstGeom prst="rect">
@@ -8017,8 +8017,8 @@
         </p:nvSpPr>
         <p:spPr>
           <a:xfrm>
-            <a:off x="8470900" y="4457700"/>
-            <a:ext cx="2654300" cy="635000"/>
+            <a:off x="8470900" y="4187952"/>
+            <a:ext cx="2654300" cy="566928"/>
           </a:xfrm>
           <a:prstGeom prst="rect">
             <a:avLst/>
@@ -8071,7 +8071,7 @@
         </p:nvSpPr>
         <p:spPr>
           <a:xfrm>
-            <a:off x="8572500" y="4597400"/>
+            <a:off x="8572500" y="4327652"/>
             <a:ext cx="2451100" cy="276999"/>
           </a:xfrm>
           <a:prstGeom prst="rect">
@@ -8111,8 +8111,8 @@
         </p:nvSpPr>
         <p:spPr>
           <a:xfrm>
-            <a:off x="635000" y="5092700"/>
-            <a:ext cx="2501900" cy="584200"/>
+            <a:off x="635000" y="4754880"/>
+            <a:ext cx="2501900" cy="566928"/>
           </a:xfrm>
           <a:prstGeom prst="rect">
             <a:avLst/>
@@ -8165,7 +8165,7 @@
         </p:nvSpPr>
         <p:spPr>
           <a:xfrm>
-            <a:off x="736600" y="5232400"/>
+            <a:off x="736600" y="4894986"/>
             <a:ext cx="2298700" cy="276999"/>
           </a:xfrm>
           <a:prstGeom prst="rect">
@@ -8205,8 +8205,8 @@
         </p:nvSpPr>
         <p:spPr>
           <a:xfrm>
-            <a:off x="3136900" y="5092700"/>
-            <a:ext cx="2667000" cy="584200"/>
+            <a:off x="3136900" y="4754880"/>
+            <a:ext cx="2667000" cy="566928"/>
           </a:xfrm>
           <a:prstGeom prst="rect">
             <a:avLst/>
@@ -8259,7 +8259,7 @@
         </p:nvSpPr>
         <p:spPr>
           <a:xfrm>
-            <a:off x="3238500" y="5232400"/>
+            <a:off x="3238500" y="4894986"/>
             <a:ext cx="2463800" cy="276999"/>
           </a:xfrm>
           <a:prstGeom prst="rect">
@@ -8299,8 +8299,8 @@
         </p:nvSpPr>
         <p:spPr>
           <a:xfrm>
-            <a:off x="5803900" y="5092700"/>
-            <a:ext cx="2667000" cy="584200"/>
+            <a:off x="5803900" y="4754880"/>
+            <a:ext cx="2667000" cy="566928"/>
           </a:xfrm>
           <a:prstGeom prst="rect">
             <a:avLst/>
@@ -8353,7 +8353,7 @@
         </p:nvSpPr>
         <p:spPr>
           <a:xfrm>
-            <a:off x="5905500" y="5232400"/>
+            <a:off x="5905500" y="4894986"/>
             <a:ext cx="2463800" cy="276999"/>
           </a:xfrm>
           <a:prstGeom prst="rect">
@@ -8393,8 +8393,8 @@
         </p:nvSpPr>
         <p:spPr>
           <a:xfrm>
-            <a:off x="8470900" y="5092700"/>
-            <a:ext cx="2654300" cy="584200"/>
+            <a:off x="8470900" y="4754880"/>
+            <a:ext cx="2654300" cy="566928"/>
           </a:xfrm>
           <a:prstGeom prst="rect">
             <a:avLst/>
@@ -8447,7 +8447,7 @@
         </p:nvSpPr>
         <p:spPr>
           <a:xfrm>
-            <a:off x="8572500" y="5232400"/>
+            <a:off x="8572500" y="4894986"/>
             <a:ext cx="2451100" cy="276999"/>
           </a:xfrm>
           <a:prstGeom prst="rect">
@@ -8487,7 +8487,7 @@
         </p:nvSpPr>
         <p:spPr>
           <a:xfrm>
-            <a:off x="1219200" y="5892800"/>
+            <a:off x="1219200" y="5989320"/>
             <a:ext cx="9753600" cy="276999"/>
           </a:xfrm>
           <a:prstGeom prst="rect">
@@ -8509,7 +8509,383 @@
                 </a:solidFill>
                 <a:latin typeface="Aptos" panose="020B0004020202020204" pitchFamily="34" charset="0"/>
               </a:rPr>
-              <a:t>Indicative, pre-tax at ₹110/€ and €100M annual portfolio. Vendor B assumes the AUM fee exceeds the annual floor; actuals require final vendor audit.</a:t>
+              <a:t>Indicative, pre-tax at ₹110/€ and €100M annual portfolio. M2P assumes the AUM fee exceeds the annual floor; actuals require final vendor audit.</a:t>
+            </a:r>
+          </a:p>
+        </p:txBody>
+      </p:sp>
+      <p:sp>
+        <p:nvSpPr>
+          <p:cNvPr id="300" name="R7rect0">
+            <a:extLst>
+              <a:ext uri="{FF2B5EF4-FFF2-40B4-BE49-F238E27FC236}">
+                <a16:creationId xmlns:a16="http://schemas.microsoft.com/office/drawing/2014/main" id="{B1ABEE59-1C77-F85D-1546-54199A64659F}"/>
+              </a:ext>
+            </a:extLst>
+          </p:cNvPr>
+          <p:cNvSpPr/>
+          <p:nvPr/>
+        </p:nvSpPr>
+        <p:spPr>
+          <a:xfrm>
+            <a:off x="635000" y="5321808"/>
+            <a:ext cx="2501900" cy="566928"/>
+          </a:xfrm>
+          <a:prstGeom prst="rect">
+            <a:avLst/>
+          </a:prstGeom>
+          <a:solidFill>
+            <a:srgbClr val="FFFFFF"/>
+          </a:solidFill>
+          <a:ln w="9525">
+            <a:solidFill>
+              <a:srgbClr val="B9D7FF"/>
+            </a:solidFill>
+          </a:ln>
+        </p:spPr>
+        <p:style>
+          <a:lnRef idx="2">
+            <a:schemeClr val="accent1">
+              <a:shade val="15000"/>
+            </a:schemeClr>
+          </a:lnRef>
+          <a:fillRef idx="1">
+            <a:schemeClr val="accent1"/>
+          </a:fillRef>
+          <a:effectRef idx="0">
+            <a:schemeClr val="accent1"/>
+          </a:effectRef>
+          <a:fontRef idx="minor">
+            <a:schemeClr val="lt1"/>
+          </a:fontRef>
+        </p:style>
+        <p:txBody>
+          <a:bodyPr rtlCol="0" anchor="ctr"/>
+          <a:lstStyle/>
+          <a:p>
+            <a:pPr algn="ctr"/>
+            <a:endParaRPr lang="en-US"/>
+          </a:p>
+        </p:txBody>
+      </p:sp>
+      <p:sp>
+        <p:nvSpPr>
+          <p:cNvPr id="301" name="R7txt0">
+            <a:extLst>
+              <a:ext uri="{FF2B5EF4-FFF2-40B4-BE49-F238E27FC236}">
+                <a16:creationId xmlns:a16="http://schemas.microsoft.com/office/drawing/2014/main" id="{05052B80-56CC-263A-E304-B1C25AAA8657}"/>
+              </a:ext>
+            </a:extLst>
+          </p:cNvPr>
+          <p:cNvSpPr txBox="1"/>
+          <p:nvPr/>
+        </p:nvSpPr>
+        <p:spPr>
+          <a:xfrm>
+            <a:off x="736600" y="5463540"/>
+            <a:ext cx="2298700" cy="276999"/>
+          </a:xfrm>
+          <a:prstGeom prst="rect">
+            <a:avLst/>
+          </a:prstGeom>
+          <a:noFill/>
+        </p:spPr>
+        <p:txBody>
+          <a:bodyPr vert="horz" wrap="square" lIns="0" tIns="0" rIns="0" bIns="0" rtlCol="0">
+            <a:noAutofit/>
+          </a:bodyPr>
+          <a:lstStyle/>
+          <a:p>
+            <a:r>
+              <a:rPr lang="en-US" sz="920" b="1">
+                <a:solidFill>
+                  <a:srgbClr val="0B1F45"/>
+                </a:solidFill>
+                <a:latin typeface="Aptos" panose="020B0004020202020204" pitchFamily="34" charset="0"/>
+              </a:rPr>
+              <a:t>Variable fees</a:t>
+            </a:r>
+          </a:p>
+        </p:txBody>
+      </p:sp>
+      <p:sp>
+        <p:nvSpPr>
+          <p:cNvPr id="302" name="R7rect1">
+            <a:extLst>
+              <a:ext uri="{FF2B5EF4-FFF2-40B4-BE49-F238E27FC236}">
+                <a16:creationId xmlns:a16="http://schemas.microsoft.com/office/drawing/2014/main" id="{379100DD-32E6-1E28-1E6F-01501705040F}"/>
+              </a:ext>
+            </a:extLst>
+          </p:cNvPr>
+          <p:cNvSpPr/>
+          <p:nvPr/>
+        </p:nvSpPr>
+        <p:spPr>
+          <a:xfrm>
+            <a:off x="3136900" y="5321808"/>
+            <a:ext cx="2667000" cy="566928"/>
+          </a:xfrm>
+          <a:prstGeom prst="rect">
+            <a:avLst/>
+          </a:prstGeom>
+          <a:solidFill>
+            <a:srgbClr val="FFFFFF"/>
+          </a:solidFill>
+          <a:ln w="9525">
+            <a:solidFill>
+              <a:srgbClr val="B9D7FF"/>
+            </a:solidFill>
+          </a:ln>
+        </p:spPr>
+        <p:style>
+          <a:lnRef idx="2">
+            <a:schemeClr val="accent1">
+              <a:shade val="15000"/>
+            </a:schemeClr>
+          </a:lnRef>
+          <a:fillRef idx="1">
+            <a:schemeClr val="accent1"/>
+          </a:fillRef>
+          <a:effectRef idx="0">
+            <a:schemeClr val="accent1"/>
+          </a:effectRef>
+          <a:fontRef idx="minor">
+            <a:schemeClr val="lt1"/>
+          </a:fontRef>
+        </p:style>
+        <p:txBody>
+          <a:bodyPr rtlCol="0" anchor="ctr"/>
+          <a:lstStyle/>
+          <a:p>
+            <a:pPr algn="ctr"/>
+            <a:endParaRPr lang="en-US"/>
+          </a:p>
+        </p:txBody>
+      </p:sp>
+      <p:sp>
+        <p:nvSpPr>
+          <p:cNvPr id="303" name="R7txt1">
+            <a:extLst>
+              <a:ext uri="{FF2B5EF4-FFF2-40B4-BE49-F238E27FC236}">
+                <a16:creationId xmlns:a16="http://schemas.microsoft.com/office/drawing/2014/main" id="{23EEC206-FD5D-2197-CDFD-879CFDF05506}"/>
+              </a:ext>
+            </a:extLst>
+          </p:cNvPr>
+          <p:cNvSpPr txBox="1"/>
+          <p:nvPr/>
+        </p:nvSpPr>
+        <p:spPr>
+          <a:xfrm>
+            <a:off x="3238500" y="5463540"/>
+            <a:ext cx="2463800" cy="276999"/>
+          </a:xfrm>
+          <a:prstGeom prst="rect">
+            <a:avLst/>
+          </a:prstGeom>
+          <a:noFill/>
+        </p:spPr>
+        <p:txBody>
+          <a:bodyPr vert="horz" wrap="square" lIns="0" tIns="0" rIns="0" bIns="0" rtlCol="0">
+            <a:noAutofit/>
+          </a:bodyPr>
+          <a:lstStyle/>
+          <a:p>
+            <a:r>
+              <a:rPr lang="en-US" sz="920">
+                <a:solidFill>
+                  <a:srgbClr val="5B6B7E"/>
+                </a:solidFill>
+                <a:latin typeface="Aptos" panose="020B0004020202020204" pitchFamily="34" charset="0"/>
+              </a:rPr>
+              <a:t>Partnership ₹5L/LSP (after first 3 free); change request ₹20k/man-day</a:t>
+            </a:r>
+          </a:p>
+        </p:txBody>
+      </p:sp>
+      <p:sp>
+        <p:nvSpPr>
+          <p:cNvPr id="304" name="R7rect2">
+            <a:extLst>
+              <a:ext uri="{FF2B5EF4-FFF2-40B4-BE49-F238E27FC236}">
+                <a16:creationId xmlns:a16="http://schemas.microsoft.com/office/drawing/2014/main" id="{D12BB0D1-F333-7974-E665-D2FB0001AFFC}"/>
+              </a:ext>
+            </a:extLst>
+          </p:cNvPr>
+          <p:cNvSpPr/>
+          <p:nvPr/>
+        </p:nvSpPr>
+        <p:spPr>
+          <a:xfrm>
+            <a:off x="5803900" y="5321808"/>
+            <a:ext cx="2667000" cy="566928"/>
+          </a:xfrm>
+          <a:prstGeom prst="rect">
+            <a:avLst/>
+          </a:prstGeom>
+          <a:solidFill>
+            <a:srgbClr val="FFFFFF"/>
+          </a:solidFill>
+          <a:ln w="9525">
+            <a:solidFill>
+              <a:srgbClr val="B9D7FF"/>
+            </a:solidFill>
+          </a:ln>
+        </p:spPr>
+        <p:style>
+          <a:lnRef idx="2">
+            <a:schemeClr val="accent1">
+              <a:shade val="15000"/>
+            </a:schemeClr>
+          </a:lnRef>
+          <a:fillRef idx="1">
+            <a:schemeClr val="accent1"/>
+          </a:fillRef>
+          <a:effectRef idx="0">
+            <a:schemeClr val="accent1"/>
+          </a:effectRef>
+          <a:fontRef idx="minor">
+            <a:schemeClr val="lt1"/>
+          </a:fontRef>
+        </p:style>
+        <p:txBody>
+          <a:bodyPr rtlCol="0" anchor="ctr"/>
+          <a:lstStyle/>
+          <a:p>
+            <a:pPr algn="ctr"/>
+            <a:endParaRPr lang="en-US"/>
+          </a:p>
+        </p:txBody>
+      </p:sp>
+      <p:sp>
+        <p:nvSpPr>
+          <p:cNvPr id="305" name="R7txt2">
+            <a:extLst>
+              <a:ext uri="{FF2B5EF4-FFF2-40B4-BE49-F238E27FC236}">
+                <a16:creationId xmlns:a16="http://schemas.microsoft.com/office/drawing/2014/main" id="{BCF98F9D-FF8F-8C20-6548-79539607223D}"/>
+              </a:ext>
+            </a:extLst>
+          </p:cNvPr>
+          <p:cNvSpPr txBox="1"/>
+          <p:nvPr/>
+        </p:nvSpPr>
+        <p:spPr>
+          <a:xfrm>
+            <a:off x="5905500" y="5463540"/>
+            <a:ext cx="2463800" cy="276999"/>
+          </a:xfrm>
+          <a:prstGeom prst="rect">
+            <a:avLst/>
+          </a:prstGeom>
+          <a:noFill/>
+        </p:spPr>
+        <p:txBody>
+          <a:bodyPr vert="horz" wrap="square" lIns="0" tIns="0" rIns="0" bIns="0" rtlCol="0">
+            <a:noAutofit/>
+          </a:bodyPr>
+          <a:lstStyle/>
+          <a:p>
+            <a:r>
+              <a:rPr lang="en-US" sz="920">
+                <a:solidFill>
+                  <a:srgbClr val="5B6B7E"/>
+                </a:solidFill>
+                <a:latin typeface="Aptos" panose="020B0004020202020204" pitchFamily="34" charset="0"/>
+              </a:rPr>
+              <a:t>Customization ₹17k/man-day</a:t>
+            </a:r>
+          </a:p>
+        </p:txBody>
+      </p:sp>
+      <p:sp>
+        <p:nvSpPr>
+          <p:cNvPr id="306" name="R7rect3">
+            <a:extLst>
+              <a:ext uri="{FF2B5EF4-FFF2-40B4-BE49-F238E27FC236}">
+                <a16:creationId xmlns:a16="http://schemas.microsoft.com/office/drawing/2014/main" id="{5B51AACA-67C6-69F5-F9A9-5AA7C32DA567}"/>
+              </a:ext>
+            </a:extLst>
+          </p:cNvPr>
+          <p:cNvSpPr/>
+          <p:nvPr/>
+        </p:nvSpPr>
+        <p:spPr>
+          <a:xfrm>
+            <a:off x="8470900" y="5321808"/>
+            <a:ext cx="2654300" cy="566928"/>
+          </a:xfrm>
+          <a:prstGeom prst="rect">
+            <a:avLst/>
+          </a:prstGeom>
+          <a:solidFill>
+            <a:srgbClr val="FFFFFF"/>
+          </a:solidFill>
+          <a:ln w="9525">
+            <a:solidFill>
+              <a:srgbClr val="B9D7FF"/>
+            </a:solidFill>
+          </a:ln>
+        </p:spPr>
+        <p:style>
+          <a:lnRef idx="2">
+            <a:schemeClr val="accent1">
+              <a:shade val="15000"/>
+            </a:schemeClr>
+          </a:lnRef>
+          <a:fillRef idx="1">
+            <a:schemeClr val="accent1"/>
+          </a:fillRef>
+          <a:effectRef idx="0">
+            <a:schemeClr val="accent1"/>
+          </a:effectRef>
+          <a:fontRef idx="minor">
+            <a:schemeClr val="lt1"/>
+          </a:fontRef>
+        </p:style>
+        <p:txBody>
+          <a:bodyPr rtlCol="0" anchor="ctr"/>
+          <a:lstStyle/>
+          <a:p>
+            <a:pPr algn="ctr"/>
+            <a:endParaRPr lang="en-US"/>
+          </a:p>
+        </p:txBody>
+      </p:sp>
+      <p:sp>
+        <p:nvSpPr>
+          <p:cNvPr id="307" name="R7txt3">
+            <a:extLst>
+              <a:ext uri="{FF2B5EF4-FFF2-40B4-BE49-F238E27FC236}">
+                <a16:creationId xmlns:a16="http://schemas.microsoft.com/office/drawing/2014/main" id="{B22101DF-6D9A-DAEA-B7D9-5821342D174A}"/>
+              </a:ext>
+            </a:extLst>
+          </p:cNvPr>
+          <p:cNvSpPr txBox="1"/>
+          <p:nvPr/>
+        </p:nvSpPr>
+        <p:spPr>
+          <a:xfrm>
+            <a:off x="8572500" y="5463540"/>
+            <a:ext cx="2451100" cy="276999"/>
+          </a:xfrm>
+          <a:prstGeom prst="rect">
+            <a:avLst/>
+          </a:prstGeom>
+          <a:noFill/>
+        </p:spPr>
+        <p:txBody>
+          <a:bodyPr vert="horz" wrap="square" lIns="0" tIns="0" rIns="0" bIns="0" rtlCol="0">
+            <a:noAutofit/>
+          </a:bodyPr>
+          <a:lstStyle/>
+          <a:p>
+            <a:r>
+              <a:rPr lang="en-US" sz="920">
+                <a:solidFill>
+                  <a:srgbClr val="5B6B7E"/>
+                </a:solidFill>
+                <a:latin typeface="Aptos" panose="020B0004020202020204" pitchFamily="34" charset="0"/>
+              </a:rPr>
+              <a:t>Internal effort only</a:t>
             </a:r>
           </a:p>
         </p:txBody>
@@ -22658,8 +23034,8 @@
         </p:nvSpPr>
         <p:spPr>
           <a:xfrm>
-            <a:off x="914400" y="1409700"/>
-            <a:ext cx="4762500" cy="1320800"/>
+            <a:off x="875996" y="1409700"/>
+            <a:ext cx="4972507" cy="1320800"/>
           </a:xfrm>
           <a:prstGeom prst="roundRect">
             <a:avLst/>
@@ -22712,7 +23088,7 @@
         </p:nvSpPr>
         <p:spPr>
           <a:xfrm>
-            <a:off x="914400" y="1409700"/>
+            <a:off x="875996" y="1409700"/>
             <a:ext cx="57150" cy="1320800"/>
           </a:xfrm>
           <a:prstGeom prst="rect">
@@ -22778,8 +23154,8 @@
         </p:nvSpPr>
         <p:spPr>
           <a:xfrm>
-            <a:off x="1193800" y="1638300"/>
-            <a:ext cx="4203700" cy="276999"/>
+            <a:off x="1155396" y="1638300"/>
+            <a:ext cx="4414723" cy="276999"/>
           </a:xfrm>
           <a:prstGeom prst="rect">
             <a:avLst/>
@@ -22818,8 +23194,8 @@
         </p:nvSpPr>
         <p:spPr>
           <a:xfrm>
-            <a:off x="1193800" y="2095500"/>
-            <a:ext cx="4203700" cy="276999"/>
+            <a:off x="1155396" y="2095500"/>
+            <a:ext cx="4414723" cy="276999"/>
           </a:xfrm>
           <a:prstGeom prst="rect">
             <a:avLst/>
@@ -22833,7 +23209,7 @@
           <a:lstStyle/>
           <a:p>
             <a:r>
-              <a:rPr lang="en-US" sz="1040">
+              <a:rPr lang="en-US" sz="1200" dirty="0">
                 <a:solidFill>
                   <a:srgbClr val="17324D"/>
                 </a:solidFill>
@@ -22858,8 +23234,8 @@
         </p:nvSpPr>
         <p:spPr>
           <a:xfrm>
-            <a:off x="6515100" y="1409700"/>
-            <a:ext cx="4762500" cy="1320800"/>
+            <a:off x="6366968" y="1409700"/>
+            <a:ext cx="4972507" cy="1320800"/>
           </a:xfrm>
           <a:prstGeom prst="roundRect">
             <a:avLst/>
@@ -22912,7 +23288,7 @@
         </p:nvSpPr>
         <p:spPr>
           <a:xfrm>
-            <a:off x="6515100" y="1409700"/>
+            <a:off x="6366968" y="1409700"/>
             <a:ext cx="57150" cy="1320800"/>
           </a:xfrm>
           <a:prstGeom prst="rect">
@@ -22978,8 +23354,8 @@
         </p:nvSpPr>
         <p:spPr>
           <a:xfrm>
-            <a:off x="6794500" y="1638300"/>
-            <a:ext cx="4203700" cy="276999"/>
+            <a:off x="6646368" y="1638300"/>
+            <a:ext cx="4414723" cy="276999"/>
           </a:xfrm>
           <a:prstGeom prst="rect">
             <a:avLst/>
@@ -23018,8 +23394,8 @@
         </p:nvSpPr>
         <p:spPr>
           <a:xfrm>
-            <a:off x="6794500" y="2095500"/>
-            <a:ext cx="4203700" cy="276999"/>
+            <a:off x="6646368" y="2095500"/>
+            <a:ext cx="4414723" cy="276999"/>
           </a:xfrm>
           <a:prstGeom prst="rect">
             <a:avLst/>
@@ -23033,7 +23409,7 @@
           <a:lstStyle/>
           <a:p>
             <a:r>
-              <a:rPr lang="en-US" sz="1080">
+              <a:rPr lang="en-US" sz="1200" dirty="0">
                 <a:solidFill>
                   <a:srgbClr val="17324D"/>
                 </a:solidFill>
@@ -23046,196 +23422,27 @@
       </p:sp>
       <p:sp>
         <p:nvSpPr>
-          <p:cNvPr id="53" name="Rectangle 52">
-            <a:extLst>
-              <a:ext uri="{FF2B5EF4-FFF2-40B4-BE49-F238E27FC236}">
-                <a16:creationId xmlns:a16="http://schemas.microsoft.com/office/drawing/2014/main" id="{3A3D2A23-479A-5F3B-D21F-01B028A7DD47}"/>
-              </a:ext>
-            </a:extLst>
-          </p:cNvPr>
-          <p:cNvSpPr/>
-          <p:nvPr/>
-        </p:nvSpPr>
-        <p:spPr>
-          <a:xfrm>
-            <a:off x="1117600" y="3073400"/>
-            <a:ext cx="9956800" cy="76200"/>
-          </a:xfrm>
-          <a:prstGeom prst="rect">
-            <a:avLst/>
-          </a:prstGeom>
-          <a:solidFill>
-            <a:srgbClr val="B9D7FF"/>
-          </a:solidFill>
-          <a:ln w="19050">
-            <a:noFill/>
-            <a:prstDash val="solid"/>
-          </a:ln>
-          <a:effectLst/>
-          <a:extLst>
-            <a:ext uri="{91240B29-F687-4F45-9708-019B960494DF}">
-              <a14:hiddenLine xmlns:a14="http://schemas.microsoft.com/office/drawing/2010/main" w="19050">
-                <a:solidFill>
-                  <a:schemeClr val="accent1">
-                    <a:shade val="15000"/>
-                  </a:schemeClr>
-                </a:solidFill>
-                <a:prstDash val="solid"/>
-              </a14:hiddenLine>
-            </a:ext>
-          </a:extLst>
-        </p:spPr>
-        <p:style>
-          <a:lnRef idx="2">
-            <a:schemeClr val="accent1">
-              <a:shade val="15000"/>
-            </a:schemeClr>
-          </a:lnRef>
-          <a:fillRef idx="1">
-            <a:schemeClr val="accent1"/>
-          </a:fillRef>
-          <a:effectRef idx="0">
-            <a:schemeClr val="accent1"/>
-          </a:effectRef>
-          <a:fontRef idx="minor">
-            <a:schemeClr val="lt1"/>
-          </a:fontRef>
-        </p:style>
-        <p:txBody>
-          <a:bodyPr rtlCol="0" anchor="ctr"/>
-          <a:lstStyle/>
-          <a:p>
-            <a:pPr algn="ctr"/>
-            <a:endParaRPr lang="en-US"/>
-          </a:p>
-        </p:txBody>
-      </p:sp>
-      <p:sp>
-        <p:nvSpPr>
-          <p:cNvPr id="54" name="Oval 53">
-            <a:extLst>
-              <a:ext uri="{FF2B5EF4-FFF2-40B4-BE49-F238E27FC236}">
-                <a16:creationId xmlns:a16="http://schemas.microsoft.com/office/drawing/2014/main" id="{62FEF3FC-D65D-224B-1701-73E16FFEA4E7}"/>
-              </a:ext>
-            </a:extLst>
-          </p:cNvPr>
-          <p:cNvSpPr/>
-          <p:nvPr/>
-        </p:nvSpPr>
-        <p:spPr>
-          <a:xfrm>
-            <a:off x="1581150" y="2863850"/>
-            <a:ext cx="457200" cy="457200"/>
-          </a:xfrm>
-          <a:prstGeom prst="ellipse">
-            <a:avLst/>
-          </a:prstGeom>
-          <a:solidFill>
-            <a:srgbClr val="1769E0"/>
-          </a:solidFill>
-          <a:ln w="19050">
-            <a:noFill/>
-            <a:prstDash val="solid"/>
-          </a:ln>
-          <a:effectLst/>
-          <a:extLst>
-            <a:ext uri="{91240B29-F687-4F45-9708-019B960494DF}">
-              <a14:hiddenLine xmlns:a14="http://schemas.microsoft.com/office/drawing/2010/main" w="19050">
-                <a:solidFill>
-                  <a:schemeClr val="accent1">
-                    <a:shade val="15000"/>
-                  </a:schemeClr>
-                </a:solidFill>
-                <a:prstDash val="solid"/>
-              </a14:hiddenLine>
-            </a:ext>
-          </a:extLst>
-        </p:spPr>
-        <p:style>
-          <a:lnRef idx="2">
-            <a:schemeClr val="accent1">
-              <a:shade val="15000"/>
-            </a:schemeClr>
-          </a:lnRef>
-          <a:fillRef idx="1">
-            <a:schemeClr val="accent1"/>
-          </a:fillRef>
-          <a:effectRef idx="0">
-            <a:schemeClr val="accent1"/>
-          </a:effectRef>
-          <a:fontRef idx="minor">
-            <a:schemeClr val="lt1"/>
-          </a:fontRef>
-        </p:style>
-        <p:txBody>
-          <a:bodyPr rtlCol="0" anchor="ctr"/>
-          <a:lstStyle/>
-          <a:p>
-            <a:pPr algn="ctr"/>
-            <a:endParaRPr lang="en-US"/>
-          </a:p>
-        </p:txBody>
-      </p:sp>
-      <p:sp>
-        <p:nvSpPr>
-          <p:cNvPr id="55" name="TextBox 54">
-            <a:extLst>
-              <a:ext uri="{FF2B5EF4-FFF2-40B4-BE49-F238E27FC236}">
-                <a16:creationId xmlns:a16="http://schemas.microsoft.com/office/drawing/2014/main" id="{84CF13C2-B976-400D-A375-6A044B96555F}"/>
-              </a:ext>
-            </a:extLst>
-          </p:cNvPr>
-          <p:cNvSpPr txBox="1"/>
-          <p:nvPr/>
-        </p:nvSpPr>
-        <p:spPr>
-          <a:xfrm>
-            <a:off x="1581150" y="2984500"/>
-            <a:ext cx="457200" cy="276999"/>
-          </a:xfrm>
-          <a:prstGeom prst="rect">
-            <a:avLst/>
-          </a:prstGeom>
-          <a:noFill/>
-        </p:spPr>
-        <p:txBody>
-          <a:bodyPr vert="horz" wrap="square" lIns="0" tIns="0" rIns="0" bIns="0" rtlCol="0">
-            <a:noAutofit/>
-          </a:bodyPr>
-          <a:lstStyle/>
-          <a:p>
-            <a:pPr algn="ctr"/>
-            <a:r>
-              <a:rPr lang="en-US" sz="1200" b="1">
-                <a:solidFill>
-                  <a:srgbClr val="FFFFFF"/>
-                </a:solidFill>
-                <a:latin typeface="Aptos" panose="020B0004020202020204" pitchFamily="34" charset="0"/>
-              </a:rPr>
-              <a:t>1</a:t>
-            </a:r>
-          </a:p>
-        </p:txBody>
-      </p:sp>
-      <p:sp>
-        <p:nvSpPr>
-          <p:cNvPr id="56" name="Rectangle: Rounded Corners 55">
-            <a:extLst>
-              <a:ext uri="{FF2B5EF4-FFF2-40B4-BE49-F238E27FC236}">
-                <a16:creationId xmlns:a16="http://schemas.microsoft.com/office/drawing/2014/main" id="{8EC23743-AB24-45CD-10D3-BE036A0C2EC7}"/>
-              </a:ext>
-            </a:extLst>
-          </p:cNvPr>
-          <p:cNvSpPr/>
-          <p:nvPr/>
-        </p:nvSpPr>
-        <p:spPr>
-          <a:xfrm>
-            <a:off x="819150" y="3860800"/>
-            <a:ext cx="2247900" cy="1549400"/>
+          <p:cNvPr id="400" name="S9_400">
+            <a:extLst>
+              <a:ext uri="{FF2B5EF4-FFF2-40B4-BE49-F238E27FC236}">
+                <a16:creationId xmlns:a16="http://schemas.microsoft.com/office/drawing/2014/main" id="{4A25A0E2-3B08-4EF9-9670-0086CE68FF82}"/>
+              </a:ext>
+            </a:extLst>
+          </p:cNvPr>
+          <p:cNvSpPr>
+            <a:spLocks noGrp="1"/>
+          </p:cNvSpPr>
+          <p:nvPr/>
+        </p:nvSpPr>
+        <p:spPr>
+          <a:xfrm>
+            <a:off x="875995" y="3337560"/>
+            <a:ext cx="2272284" cy="1481328"/>
           </a:xfrm>
           <a:prstGeom prst="roundRect">
-            <a:avLst/>
+            <a:avLst>
+              <a:gd name="adj" fmla="val 8824"/>
+            </a:avLst>
           </a:prstGeom>
           <a:solidFill>
             <a:srgbClr val="EAF3FF"/>
@@ -23244,324 +23451,276 @@
             <a:solidFill>
               <a:srgbClr val="B9D7FF"/>
             </a:solidFill>
-          </a:ln>
-        </p:spPr>
-        <p:style>
-          <a:lnRef idx="2">
-            <a:schemeClr val="accent1">
-              <a:shade val="15000"/>
-            </a:schemeClr>
-          </a:lnRef>
-          <a:fillRef idx="1">
-            <a:schemeClr val="accent1"/>
-          </a:fillRef>
-          <a:effectRef idx="0">
-            <a:schemeClr val="accent1"/>
-          </a:effectRef>
-          <a:fontRef idx="minor">
-            <a:schemeClr val="lt1"/>
-          </a:fontRef>
-        </p:style>
-        <p:txBody>
-          <a:bodyPr rtlCol="0" anchor="ctr"/>
-          <a:lstStyle/>
-          <a:p>
-            <a:pPr algn="ctr"/>
-            <a:endParaRPr lang="en-US"/>
-          </a:p>
-        </p:txBody>
-      </p:sp>
-      <p:sp>
-        <p:nvSpPr>
-          <p:cNvPr id="57" name="Rectangle 56">
-            <a:extLst>
-              <a:ext uri="{FF2B5EF4-FFF2-40B4-BE49-F238E27FC236}">
-                <a16:creationId xmlns:a16="http://schemas.microsoft.com/office/drawing/2014/main" id="{31B149E8-28DB-53A4-115D-8BD509D2F9E1}"/>
-              </a:ext>
-            </a:extLst>
-          </p:cNvPr>
-          <p:cNvSpPr/>
-          <p:nvPr/>
-        </p:nvSpPr>
-        <p:spPr>
-          <a:xfrm>
-            <a:off x="819150" y="3860800"/>
-            <a:ext cx="57150" cy="1549400"/>
-          </a:xfrm>
-          <a:prstGeom prst="rect">
+            <a:prstDash val="solid"/>
+          </a:ln>
+        </p:spPr>
+        <p:txBody>
+          <a:bodyPr/>
+          <a:lstStyle/>
+          <a:p>
+            <a:endParaRPr/>
+          </a:p>
+        </p:txBody>
+      </p:sp>
+      <p:sp>
+        <p:nvSpPr>
+          <p:cNvPr id="401" name="S9_401">
+            <a:extLst>
+              <a:ext uri="{FF2B5EF4-FFF2-40B4-BE49-F238E27FC236}">
+                <a16:creationId xmlns:a16="http://schemas.microsoft.com/office/drawing/2014/main" id="{FA95580C-3751-410A-B40F-5151F33E4E90}"/>
+              </a:ext>
+            </a:extLst>
+          </p:cNvPr>
+          <p:cNvSpPr>
+            <a:spLocks noGrp="1"/>
+          </p:cNvSpPr>
+          <p:nvPr/>
+        </p:nvSpPr>
+        <p:spPr>
+          <a:xfrm>
+            <a:off x="1028700" y="3489350"/>
+            <a:ext cx="323850" cy="323850"/>
+          </a:xfrm>
+          <a:prstGeom prst="ellipse">
             <a:avLst/>
           </a:prstGeom>
           <a:solidFill>
-            <a:srgbClr val="1769E0"/>
+            <a:srgbClr val="0B1F45"/>
           </a:solidFill>
-          <a:ln w="19050">
+          <a:ln w="9525">
+            <a:solidFill>
+              <a:srgbClr val="0B1F45"/>
+            </a:solidFill>
+            <a:prstDash val="solid"/>
+          </a:ln>
+        </p:spPr>
+        <p:txBody>
+          <a:bodyPr/>
+          <a:lstStyle/>
+          <a:p>
+            <a:endParaRPr/>
+          </a:p>
+        </p:txBody>
+      </p:sp>
+      <p:sp>
+        <p:nvSpPr>
+          <p:cNvPr id="402" name="S9_402">
+            <a:extLst>
+              <a:ext uri="{FF2B5EF4-FFF2-40B4-BE49-F238E27FC236}">
+                <a16:creationId xmlns:a16="http://schemas.microsoft.com/office/drawing/2014/main" id="{989FCBBA-16A3-4184-AD96-4EA22B238358}"/>
+              </a:ext>
+            </a:extLst>
+          </p:cNvPr>
+          <p:cNvSpPr>
+            <a:spLocks noGrp="1"/>
+          </p:cNvSpPr>
+          <p:nvPr/>
+        </p:nvSpPr>
+        <p:spPr>
+          <a:xfrm>
+            <a:off x="1028700" y="3546957"/>
+            <a:ext cx="323850" cy="171450"/>
+          </a:xfrm>
+          <a:prstGeom prst="rect">
+            <a:avLst/>
+          </a:prstGeom>
+          <a:noFill/>
+          <a:ln w="0">
             <a:noFill/>
             <a:prstDash val="solid"/>
           </a:ln>
-          <a:effectLst/>
-          <a:extLst>
-            <a:ext uri="{91240B29-F687-4F45-9708-019B960494DF}">
-              <a14:hiddenLine xmlns:a14="http://schemas.microsoft.com/office/drawing/2010/main" w="19050">
-                <a:solidFill>
-                  <a:schemeClr val="accent1">
-                    <a:shade val="15000"/>
-                  </a:schemeClr>
-                </a:solidFill>
-                <a:prstDash val="solid"/>
-              </a14:hiddenLine>
-            </a:ext>
-          </a:extLst>
-        </p:spPr>
-        <p:style>
-          <a:lnRef idx="2">
-            <a:schemeClr val="accent1">
-              <a:shade val="15000"/>
-            </a:schemeClr>
-          </a:lnRef>
-          <a:fillRef idx="1">
-            <a:schemeClr val="accent1"/>
-          </a:fillRef>
-          <a:effectRef idx="0">
-            <a:schemeClr val="accent1"/>
-          </a:effectRef>
-          <a:fontRef idx="minor">
-            <a:schemeClr val="lt1"/>
-          </a:fontRef>
-        </p:style>
-        <p:txBody>
-          <a:bodyPr rtlCol="0" anchor="ctr"/>
-          <a:lstStyle/>
-          <a:p>
-            <a:pPr algn="ctr"/>
-            <a:endParaRPr lang="en-US"/>
-          </a:p>
-        </p:txBody>
-      </p:sp>
-      <p:sp>
-        <p:nvSpPr>
-          <p:cNvPr id="58" name="TextBox 57">
-            <a:extLst>
-              <a:ext uri="{FF2B5EF4-FFF2-40B4-BE49-F238E27FC236}">
-                <a16:creationId xmlns:a16="http://schemas.microsoft.com/office/drawing/2014/main" id="{06F77997-E474-9CBC-426D-894918A73660}"/>
-              </a:ext>
-            </a:extLst>
-          </p:cNvPr>
-          <p:cNvSpPr txBox="1"/>
-          <p:nvPr/>
-        </p:nvSpPr>
-        <p:spPr>
-          <a:xfrm>
-            <a:off x="1098550" y="4089400"/>
-            <a:ext cx="1689100" cy="276999"/>
-          </a:xfrm>
-          <a:prstGeom prst="rect">
-            <a:avLst/>
-          </a:prstGeom>
-          <a:noFill/>
-        </p:spPr>
-        <p:txBody>
-          <a:bodyPr vert="horz" wrap="square" lIns="0" tIns="0" rIns="0" bIns="0" rtlCol="0">
-            <a:noAutofit/>
-          </a:bodyPr>
-          <a:lstStyle/>
-          <a:p>
-            <a:r>
-              <a:rPr lang="en-US" sz="1450" b="1">
+        </p:spPr>
+        <p:txBody>
+          <a:bodyPr/>
+          <a:lstStyle/>
+          <a:p>
+            <a:pPr algn="ctr">
+              <a:defRPr sz="1050" b="1">
+                <a:solidFill>
+                  <a:srgbClr val="FFFFFF"/>
+                </a:solidFill>
+                <a:latin typeface="Aptos"/>
+                <a:ea typeface="Aptos"/>
+                <a:cs typeface="Aptos"/>
+              </a:defRPr>
+            </a:pPr>
+            <a:r>
+              <a:rPr sz="1050" b="1">
+                <a:solidFill>
+                  <a:srgbClr val="FFFFFF"/>
+                </a:solidFill>
+                <a:latin typeface="Aptos"/>
+                <a:ea typeface="Aptos"/>
+                <a:cs typeface="Aptos"/>
+              </a:rPr>
+              <a:t>1</a:t>
+            </a:r>
+          </a:p>
+        </p:txBody>
+      </p:sp>
+      <p:sp>
+        <p:nvSpPr>
+          <p:cNvPr id="403" name="S9_403">
+            <a:extLst>
+              <a:ext uri="{FF2B5EF4-FFF2-40B4-BE49-F238E27FC236}">
+                <a16:creationId xmlns:a16="http://schemas.microsoft.com/office/drawing/2014/main" id="{4ACAF123-CFF1-4B97-AD51-6219B4766F97}"/>
+              </a:ext>
+            </a:extLst>
+          </p:cNvPr>
+          <p:cNvSpPr>
+            <a:spLocks noGrp="1"/>
+          </p:cNvSpPr>
+          <p:nvPr/>
+        </p:nvSpPr>
+        <p:spPr>
+          <a:xfrm>
+            <a:off x="1406232" y="3495209"/>
+            <a:ext cx="1613001" cy="512064"/>
+          </a:xfrm>
+          <a:prstGeom prst="rect">
+            <a:avLst/>
+          </a:prstGeom>
+          <a:noFill/>
+          <a:ln w="0">
+            <a:noFill/>
+            <a:prstDash val="solid"/>
+          </a:ln>
+        </p:spPr>
+        <p:txBody>
+          <a:bodyPr/>
+          <a:lstStyle/>
+          <a:p>
+            <a:pPr algn="l">
+              <a:defRPr sz="1200" b="1">
                 <a:solidFill>
                   <a:srgbClr val="0B1F45"/>
                 </a:solidFill>
-                <a:latin typeface="Aptos" panose="020B0004020202020204" pitchFamily="34" charset="0"/>
-              </a:rPr>
-              <a:t>0-1 month</a:t>
-            </a:r>
-          </a:p>
-        </p:txBody>
-      </p:sp>
-      <p:sp>
-        <p:nvSpPr>
-          <p:cNvPr id="59" name="TextBox 58">
-            <a:extLst>
-              <a:ext uri="{FF2B5EF4-FFF2-40B4-BE49-F238E27FC236}">
-                <a16:creationId xmlns:a16="http://schemas.microsoft.com/office/drawing/2014/main" id="{0F35FD7E-A1F9-4473-2678-9029EED4B8CC}"/>
-              </a:ext>
-            </a:extLst>
-          </p:cNvPr>
-          <p:cNvSpPr txBox="1"/>
-          <p:nvPr/>
-        </p:nvSpPr>
-        <p:spPr>
-          <a:xfrm>
-            <a:off x="1098550" y="4546600"/>
-            <a:ext cx="1689100" cy="276999"/>
-          </a:xfrm>
-          <a:prstGeom prst="rect">
-            <a:avLst/>
-          </a:prstGeom>
-          <a:noFill/>
-        </p:spPr>
-        <p:txBody>
-          <a:bodyPr vert="horz" wrap="square" lIns="0" tIns="0" rIns="0" bIns="0" rtlCol="0">
-            <a:noAutofit/>
-          </a:bodyPr>
-          <a:lstStyle/>
-          <a:p>
-            <a:r>
-              <a:rPr lang="en-US" sz="1080">
+                <a:latin typeface="Aptos"/>
+                <a:ea typeface="Aptos"/>
+                <a:cs typeface="Aptos"/>
+              </a:defRPr>
+            </a:pPr>
+            <a:r>
+              <a:rPr sz="1100" b="1" dirty="0">
+                <a:solidFill>
+                  <a:srgbClr val="0B1F45"/>
+                </a:solidFill>
+                <a:latin typeface="Aptos"/>
+                <a:ea typeface="Aptos"/>
+                <a:cs typeface="Aptos"/>
+              </a:rPr>
+              <a:t>0–1 month</a:t>
+            </a:r>
+          </a:p>
+          <a:p>
+            <a:pPr>
+              <a:spcBef>
+                <a:spcPts val="100"/>
+              </a:spcBef>
+              <a:spcAft>
+                <a:spcPts val="0"/>
+              </a:spcAft>
+            </a:pPr>
+            <a:r>
+              <a:rPr sz="1100" b="1" dirty="0">
+                <a:solidFill>
+                  <a:srgbClr val="1769E0"/>
+                </a:solidFill>
+                <a:latin typeface="Aptos"/>
+              </a:rPr>
+              <a:t>Jul 2026</a:t>
+            </a:r>
+          </a:p>
+        </p:txBody>
+      </p:sp>
+      <p:sp>
+        <p:nvSpPr>
+          <p:cNvPr id="404" name="S9_404">
+            <a:extLst>
+              <a:ext uri="{FF2B5EF4-FFF2-40B4-BE49-F238E27FC236}">
+                <a16:creationId xmlns:a16="http://schemas.microsoft.com/office/drawing/2014/main" id="{2C69A05C-4BB7-49E1-9BC0-B8B07A245E3B}"/>
+              </a:ext>
+            </a:extLst>
+          </p:cNvPr>
+          <p:cNvSpPr>
+            <a:spLocks noGrp="1"/>
+          </p:cNvSpPr>
+          <p:nvPr/>
+        </p:nvSpPr>
+        <p:spPr>
+          <a:xfrm>
+            <a:off x="1047902" y="3922776"/>
+            <a:ext cx="1928469" cy="804672"/>
+          </a:xfrm>
+          <a:prstGeom prst="rect">
+            <a:avLst/>
+          </a:prstGeom>
+          <a:noFill/>
+          <a:ln w="0">
+            <a:noFill/>
+            <a:prstDash val="solid"/>
+          </a:ln>
+        </p:spPr>
+        <p:txBody>
+          <a:bodyPr/>
+          <a:lstStyle/>
+          <a:p>
+            <a:pPr algn="l">
+              <a:defRPr sz="1013" b="0">
                 <a:solidFill>
                   <a:srgbClr val="17324D"/>
                 </a:solidFill>
-                <a:latin typeface="Aptos" panose="020B0004020202020204" pitchFamily="34" charset="0"/>
+                <a:latin typeface="Aptos"/>
+                <a:ea typeface="Aptos"/>
+                <a:cs typeface="Aptos"/>
+              </a:defRPr>
+            </a:pPr>
+            <a:r>
+              <a:rPr sz="1100" b="1" dirty="0">
+                <a:solidFill>
+                  <a:srgbClr val="0B1F45"/>
+                </a:solidFill>
+                <a:latin typeface="Aptos"/>
               </a:rPr>
               <a:t>Decision and scope</a:t>
             </a:r>
           </a:p>
           <a:p>
-            <a:endParaRPr lang="en-US" sz="1080">
-              <a:solidFill>
-                <a:srgbClr val="17324D"/>
-              </a:solidFill>
-              <a:latin typeface="Aptos" panose="020B0004020202020204" pitchFamily="34" charset="0"/>
-            </a:endParaRPr>
-          </a:p>
-          <a:p>
-            <a:r>
-              <a:rPr lang="en-US" sz="1080">
+            <a:r>
+              <a:rPr sz="1100" b="0" dirty="0">
                 <a:solidFill>
                   <a:srgbClr val="17324D"/>
                 </a:solidFill>
-                <a:latin typeface="Aptos" panose="020B0004020202020204" pitchFamily="34" charset="0"/>
-              </a:rPr>
-              <a:t>Confirm owner, target process, LSP value case.</a:t>
-            </a:r>
-          </a:p>
-        </p:txBody>
-      </p:sp>
-      <p:sp>
-        <p:nvSpPr>
-          <p:cNvPr id="60" name="Oval 59">
-            <a:extLst>
-              <a:ext uri="{FF2B5EF4-FFF2-40B4-BE49-F238E27FC236}">
-                <a16:creationId xmlns:a16="http://schemas.microsoft.com/office/drawing/2014/main" id="{717DAA91-774D-303B-8CDE-CC8171085994}"/>
-              </a:ext>
-            </a:extLst>
-          </p:cNvPr>
-          <p:cNvSpPr/>
-          <p:nvPr/>
-        </p:nvSpPr>
-        <p:spPr>
-          <a:xfrm>
-            <a:off x="4362450" y="2863850"/>
-            <a:ext cx="457200" cy="457200"/>
-          </a:xfrm>
-          <a:prstGeom prst="ellipse">
-            <a:avLst/>
-          </a:prstGeom>
-          <a:solidFill>
-            <a:srgbClr val="1769E0"/>
-          </a:solidFill>
-          <a:ln w="19050">
-            <a:noFill/>
-            <a:prstDash val="solid"/>
-          </a:ln>
-          <a:effectLst/>
-          <a:extLst>
-            <a:ext uri="{91240B29-F687-4F45-9708-019B960494DF}">
-              <a14:hiddenLine xmlns:a14="http://schemas.microsoft.com/office/drawing/2010/main" w="19050">
-                <a:solidFill>
-                  <a:schemeClr val="accent1">
-                    <a:shade val="15000"/>
-                  </a:schemeClr>
-                </a:solidFill>
-                <a:prstDash val="solid"/>
-              </a14:hiddenLine>
-            </a:ext>
-          </a:extLst>
-        </p:spPr>
-        <p:style>
-          <a:lnRef idx="2">
-            <a:schemeClr val="accent1">
-              <a:shade val="15000"/>
-            </a:schemeClr>
-          </a:lnRef>
-          <a:fillRef idx="1">
-            <a:schemeClr val="accent1"/>
-          </a:fillRef>
-          <a:effectRef idx="0">
-            <a:schemeClr val="accent1"/>
-          </a:effectRef>
-          <a:fontRef idx="minor">
-            <a:schemeClr val="lt1"/>
-          </a:fontRef>
-        </p:style>
-        <p:txBody>
-          <a:bodyPr rtlCol="0" anchor="ctr"/>
-          <a:lstStyle/>
-          <a:p>
-            <a:pPr algn="ctr"/>
-            <a:endParaRPr lang="en-US"/>
-          </a:p>
-        </p:txBody>
-      </p:sp>
-      <p:sp>
-        <p:nvSpPr>
-          <p:cNvPr id="61" name="TextBox 60">
-            <a:extLst>
-              <a:ext uri="{FF2B5EF4-FFF2-40B4-BE49-F238E27FC236}">
-                <a16:creationId xmlns:a16="http://schemas.microsoft.com/office/drawing/2014/main" id="{66264607-7577-3338-FE25-F4A4F8956CDE}"/>
-              </a:ext>
-            </a:extLst>
-          </p:cNvPr>
-          <p:cNvSpPr txBox="1"/>
-          <p:nvPr/>
-        </p:nvSpPr>
-        <p:spPr>
-          <a:xfrm>
-            <a:off x="4362450" y="2984500"/>
-            <a:ext cx="457200" cy="276999"/>
-          </a:xfrm>
-          <a:prstGeom prst="rect">
-            <a:avLst/>
-          </a:prstGeom>
-          <a:noFill/>
-        </p:spPr>
-        <p:txBody>
-          <a:bodyPr vert="horz" wrap="square" lIns="0" tIns="0" rIns="0" bIns="0" rtlCol="0">
-            <a:noAutofit/>
-          </a:bodyPr>
-          <a:lstStyle/>
-          <a:p>
-            <a:pPr algn="ctr"/>
-            <a:r>
-              <a:rPr lang="en-US" sz="1200" b="1">
-                <a:solidFill>
-                  <a:srgbClr val="FFFFFF"/>
-                </a:solidFill>
-                <a:latin typeface="Aptos" panose="020B0004020202020204" pitchFamily="34" charset="0"/>
-              </a:rPr>
-              <a:t>2</a:t>
-            </a:r>
-          </a:p>
-        </p:txBody>
-      </p:sp>
-      <p:sp>
-        <p:nvSpPr>
-          <p:cNvPr id="62" name="Rectangle: Rounded Corners 61">
-            <a:extLst>
-              <a:ext uri="{FF2B5EF4-FFF2-40B4-BE49-F238E27FC236}">
-                <a16:creationId xmlns:a16="http://schemas.microsoft.com/office/drawing/2014/main" id="{CADA7A8C-EDC9-B64E-6528-D6A83EDDF256}"/>
-              </a:ext>
-            </a:extLst>
-          </p:cNvPr>
-          <p:cNvSpPr/>
-          <p:nvPr/>
-        </p:nvSpPr>
-        <p:spPr>
-          <a:xfrm>
-            <a:off x="3600450" y="3860800"/>
-            <a:ext cx="2247900" cy="1549400"/>
+                <a:latin typeface="Aptos"/>
+              </a:rPr>
+              <a:t>Confirm owner, target process, and LSP value case.</a:t>
+            </a:r>
+          </a:p>
+        </p:txBody>
+      </p:sp>
+      <p:sp>
+        <p:nvSpPr>
+          <p:cNvPr id="405" name="S9_405">
+            <a:extLst>
+              <a:ext uri="{FF2B5EF4-FFF2-40B4-BE49-F238E27FC236}">
+                <a16:creationId xmlns:a16="http://schemas.microsoft.com/office/drawing/2014/main" id="{7608177E-0023-41DB-9241-93A38321285E}"/>
+              </a:ext>
+            </a:extLst>
+          </p:cNvPr>
+          <p:cNvSpPr>
+            <a:spLocks noGrp="1"/>
+          </p:cNvSpPr>
+          <p:nvPr/>
+        </p:nvSpPr>
+        <p:spPr>
+          <a:xfrm>
+            <a:off x="3605479" y="3337560"/>
+            <a:ext cx="2272284" cy="1481328"/>
           </a:xfrm>
           <a:prstGeom prst="roundRect">
-            <a:avLst/>
+            <a:avLst>
+              <a:gd name="adj" fmla="val 8824"/>
+            </a:avLst>
           </a:prstGeom>
           <a:solidFill>
             <a:srgbClr val="EAF3FF"/>
@@ -23570,324 +23729,294 @@
             <a:solidFill>
               <a:srgbClr val="B9D7FF"/>
             </a:solidFill>
-          </a:ln>
-        </p:spPr>
-        <p:style>
-          <a:lnRef idx="2">
-            <a:schemeClr val="accent1">
-              <a:shade val="15000"/>
-            </a:schemeClr>
-          </a:lnRef>
-          <a:fillRef idx="1">
-            <a:schemeClr val="accent1"/>
-          </a:fillRef>
-          <a:effectRef idx="0">
-            <a:schemeClr val="accent1"/>
-          </a:effectRef>
-          <a:fontRef idx="minor">
-            <a:schemeClr val="lt1"/>
-          </a:fontRef>
-        </p:style>
-        <p:txBody>
-          <a:bodyPr rtlCol="0" anchor="ctr"/>
-          <a:lstStyle/>
-          <a:p>
-            <a:pPr algn="ctr"/>
-            <a:endParaRPr lang="en-US"/>
-          </a:p>
-        </p:txBody>
-      </p:sp>
-      <p:sp>
-        <p:nvSpPr>
-          <p:cNvPr id="63" name="Rectangle 62">
-            <a:extLst>
-              <a:ext uri="{FF2B5EF4-FFF2-40B4-BE49-F238E27FC236}">
-                <a16:creationId xmlns:a16="http://schemas.microsoft.com/office/drawing/2014/main" id="{2EEB7182-287F-4CE8-A824-4BADC3526F4A}"/>
-              </a:ext>
-            </a:extLst>
-          </p:cNvPr>
-          <p:cNvSpPr/>
-          <p:nvPr/>
-        </p:nvSpPr>
-        <p:spPr>
-          <a:xfrm>
-            <a:off x="3600450" y="3860800"/>
-            <a:ext cx="57150" cy="1549400"/>
-          </a:xfrm>
-          <a:prstGeom prst="rect">
+            <a:prstDash val="solid"/>
+          </a:ln>
+        </p:spPr>
+        <p:txBody>
+          <a:bodyPr/>
+          <a:lstStyle/>
+          <a:p>
+            <a:endParaRPr/>
+          </a:p>
+        </p:txBody>
+      </p:sp>
+      <p:sp>
+        <p:nvSpPr>
+          <p:cNvPr id="406" name="S9_406">
+            <a:extLst>
+              <a:ext uri="{FF2B5EF4-FFF2-40B4-BE49-F238E27FC236}">
+                <a16:creationId xmlns:a16="http://schemas.microsoft.com/office/drawing/2014/main" id="{03DF20E9-8ADD-44A6-A451-B587C0C53C37}"/>
+              </a:ext>
+            </a:extLst>
+          </p:cNvPr>
+          <p:cNvSpPr>
+            <a:spLocks noGrp="1"/>
+          </p:cNvSpPr>
+          <p:nvPr/>
+        </p:nvSpPr>
+        <p:spPr>
+          <a:xfrm>
+            <a:off x="3758184" y="3489350"/>
+            <a:ext cx="323850" cy="323850"/>
+          </a:xfrm>
+          <a:prstGeom prst="ellipse">
             <a:avLst/>
           </a:prstGeom>
           <a:solidFill>
-            <a:srgbClr val="1769E0"/>
+            <a:srgbClr val="0B1F45"/>
           </a:solidFill>
-          <a:ln w="19050">
+          <a:ln w="9525">
+            <a:solidFill>
+              <a:srgbClr val="0B1F45"/>
+            </a:solidFill>
+            <a:prstDash val="solid"/>
+          </a:ln>
+        </p:spPr>
+        <p:txBody>
+          <a:bodyPr/>
+          <a:lstStyle/>
+          <a:p>
+            <a:endParaRPr/>
+          </a:p>
+        </p:txBody>
+      </p:sp>
+      <p:sp>
+        <p:nvSpPr>
+          <p:cNvPr id="407" name="S9_407">
+            <a:extLst>
+              <a:ext uri="{FF2B5EF4-FFF2-40B4-BE49-F238E27FC236}">
+                <a16:creationId xmlns:a16="http://schemas.microsoft.com/office/drawing/2014/main" id="{74055FEA-ADA8-4253-ACCF-8E00AA8F53B8}"/>
+              </a:ext>
+            </a:extLst>
+          </p:cNvPr>
+          <p:cNvSpPr>
+            <a:spLocks noGrp="1"/>
+          </p:cNvSpPr>
+          <p:nvPr/>
+        </p:nvSpPr>
+        <p:spPr>
+          <a:xfrm>
+            <a:off x="3758184" y="3546957"/>
+            <a:ext cx="323850" cy="171450"/>
+          </a:xfrm>
+          <a:prstGeom prst="rect">
+            <a:avLst/>
+          </a:prstGeom>
+          <a:noFill/>
+          <a:ln w="0">
             <a:noFill/>
             <a:prstDash val="solid"/>
           </a:ln>
-          <a:effectLst/>
-          <a:extLst>
-            <a:ext uri="{91240B29-F687-4F45-9708-019B960494DF}">
-              <a14:hiddenLine xmlns:a14="http://schemas.microsoft.com/office/drawing/2010/main" w="19050">
-                <a:solidFill>
-                  <a:schemeClr val="accent1">
-                    <a:shade val="15000"/>
-                  </a:schemeClr>
-                </a:solidFill>
-                <a:prstDash val="solid"/>
-              </a14:hiddenLine>
-            </a:ext>
-          </a:extLst>
-        </p:spPr>
-        <p:style>
-          <a:lnRef idx="2">
-            <a:schemeClr val="accent1">
-              <a:shade val="15000"/>
-            </a:schemeClr>
-          </a:lnRef>
-          <a:fillRef idx="1">
-            <a:schemeClr val="accent1"/>
-          </a:fillRef>
-          <a:effectRef idx="0">
-            <a:schemeClr val="accent1"/>
-          </a:effectRef>
-          <a:fontRef idx="minor">
-            <a:schemeClr val="lt1"/>
-          </a:fontRef>
-        </p:style>
-        <p:txBody>
-          <a:bodyPr rtlCol="0" anchor="ctr"/>
-          <a:lstStyle/>
-          <a:p>
-            <a:pPr algn="ctr"/>
-            <a:endParaRPr lang="en-US"/>
-          </a:p>
-        </p:txBody>
-      </p:sp>
-      <p:sp>
-        <p:nvSpPr>
-          <p:cNvPr id="64" name="TextBox 63">
-            <a:extLst>
-              <a:ext uri="{FF2B5EF4-FFF2-40B4-BE49-F238E27FC236}">
-                <a16:creationId xmlns:a16="http://schemas.microsoft.com/office/drawing/2014/main" id="{AB6FF38E-2799-9B5A-C736-259CD82671C9}"/>
-              </a:ext>
-            </a:extLst>
-          </p:cNvPr>
-          <p:cNvSpPr txBox="1"/>
-          <p:nvPr/>
-        </p:nvSpPr>
-        <p:spPr>
-          <a:xfrm>
-            <a:off x="3879850" y="4089400"/>
-            <a:ext cx="1689100" cy="276999"/>
-          </a:xfrm>
-          <a:prstGeom prst="rect">
-            <a:avLst/>
-          </a:prstGeom>
-          <a:noFill/>
-        </p:spPr>
-        <p:txBody>
-          <a:bodyPr vert="horz" wrap="square" lIns="0" tIns="0" rIns="0" bIns="0" rtlCol="0">
-            <a:noAutofit/>
-          </a:bodyPr>
-          <a:lstStyle/>
-          <a:p>
-            <a:r>
-              <a:rPr lang="en-US" sz="1450" b="1">
+        </p:spPr>
+        <p:txBody>
+          <a:bodyPr/>
+          <a:lstStyle/>
+          <a:p>
+            <a:pPr algn="ctr">
+              <a:defRPr sz="1050" b="1">
+                <a:solidFill>
+                  <a:srgbClr val="FFFFFF"/>
+                </a:solidFill>
+                <a:latin typeface="Aptos"/>
+                <a:ea typeface="Aptos"/>
+                <a:cs typeface="Aptos"/>
+              </a:defRPr>
+            </a:pPr>
+            <a:r>
+              <a:rPr sz="1050" b="1">
+                <a:solidFill>
+                  <a:srgbClr val="FFFFFF"/>
+                </a:solidFill>
+                <a:latin typeface="Aptos"/>
+                <a:ea typeface="Aptos"/>
+                <a:cs typeface="Aptos"/>
+              </a:rPr>
+              <a:t>2</a:t>
+            </a:r>
+          </a:p>
+        </p:txBody>
+      </p:sp>
+      <p:sp>
+        <p:nvSpPr>
+          <p:cNvPr id="408" name="S9_408">
+            <a:extLst>
+              <a:ext uri="{FF2B5EF4-FFF2-40B4-BE49-F238E27FC236}">
+                <a16:creationId xmlns:a16="http://schemas.microsoft.com/office/drawing/2014/main" id="{D987BE79-14A0-4D35-8715-1737D796CC50}"/>
+              </a:ext>
+            </a:extLst>
+          </p:cNvPr>
+          <p:cNvSpPr>
+            <a:spLocks noGrp="1"/>
+          </p:cNvSpPr>
+          <p:nvPr/>
+        </p:nvSpPr>
+        <p:spPr>
+          <a:xfrm>
+            <a:off x="4126565" y="3466831"/>
+            <a:ext cx="1613001" cy="512064"/>
+          </a:xfrm>
+          <a:prstGeom prst="rect">
+            <a:avLst/>
+          </a:prstGeom>
+          <a:noFill/>
+          <a:ln w="0">
+            <a:noFill/>
+            <a:prstDash val="solid"/>
+          </a:ln>
+        </p:spPr>
+        <p:txBody>
+          <a:bodyPr/>
+          <a:lstStyle/>
+          <a:p>
+            <a:pPr algn="l">
+              <a:defRPr sz="1200" b="1">
                 <a:solidFill>
                   <a:srgbClr val="0B1F45"/>
                 </a:solidFill>
-                <a:latin typeface="Aptos" panose="020B0004020202020204" pitchFamily="34" charset="0"/>
-              </a:rPr>
-              <a:t>1-3 months</a:t>
-            </a:r>
-          </a:p>
-        </p:txBody>
-      </p:sp>
-      <p:sp>
-        <p:nvSpPr>
-          <p:cNvPr id="65" name="TextBox 64">
-            <a:extLst>
-              <a:ext uri="{FF2B5EF4-FFF2-40B4-BE49-F238E27FC236}">
-                <a16:creationId xmlns:a16="http://schemas.microsoft.com/office/drawing/2014/main" id="{500F8A3E-5698-ACC0-1D46-97330266CEED}"/>
-              </a:ext>
-            </a:extLst>
-          </p:cNvPr>
-          <p:cNvSpPr txBox="1"/>
-          <p:nvPr/>
-        </p:nvSpPr>
-        <p:spPr>
-          <a:xfrm>
-            <a:off x="3879850" y="4546600"/>
-            <a:ext cx="1689100" cy="276999"/>
-          </a:xfrm>
-          <a:prstGeom prst="rect">
-            <a:avLst/>
-          </a:prstGeom>
-          <a:noFill/>
-        </p:spPr>
-        <p:txBody>
-          <a:bodyPr vert="horz" wrap="square" lIns="0" tIns="0" rIns="0" bIns="0" rtlCol="0">
-            <a:noAutofit/>
-          </a:bodyPr>
-          <a:lstStyle/>
-          <a:p>
-            <a:r>
-              <a:rPr lang="en-US" sz="1080">
+                <a:latin typeface="Aptos"/>
+                <a:ea typeface="Aptos"/>
+                <a:cs typeface="Aptos"/>
+              </a:defRPr>
+            </a:pPr>
+            <a:r>
+              <a:rPr sz="1100" b="1" dirty="0">
+                <a:solidFill>
+                  <a:srgbClr val="0B1F45"/>
+                </a:solidFill>
+                <a:latin typeface="Aptos"/>
+                <a:ea typeface="Aptos"/>
+                <a:cs typeface="Aptos"/>
+              </a:rPr>
+              <a:t>1–3 months</a:t>
+            </a:r>
+          </a:p>
+          <a:p>
+            <a:pPr>
+              <a:spcBef>
+                <a:spcPts val="100"/>
+              </a:spcBef>
+              <a:spcAft>
+                <a:spcPts val="0"/>
+              </a:spcAft>
+            </a:pPr>
+            <a:r>
+              <a:rPr sz="1100" b="1" dirty="0">
+                <a:solidFill>
+                  <a:srgbClr val="1769E0"/>
+                </a:solidFill>
+                <a:latin typeface="Aptos"/>
+              </a:rPr>
+              <a:t>Aug–Sep 2026</a:t>
+            </a:r>
+          </a:p>
+        </p:txBody>
+      </p:sp>
+      <p:sp>
+        <p:nvSpPr>
+          <p:cNvPr id="409" name="S9_409">
+            <a:extLst>
+              <a:ext uri="{FF2B5EF4-FFF2-40B4-BE49-F238E27FC236}">
+                <a16:creationId xmlns:a16="http://schemas.microsoft.com/office/drawing/2014/main" id="{EE0390E2-013D-4B78-8500-E3855B1947F9}"/>
+              </a:ext>
+            </a:extLst>
+          </p:cNvPr>
+          <p:cNvSpPr>
+            <a:spLocks noGrp="1"/>
+          </p:cNvSpPr>
+          <p:nvPr/>
+        </p:nvSpPr>
+        <p:spPr>
+          <a:xfrm>
+            <a:off x="3777386" y="3974439"/>
+            <a:ext cx="1928469" cy="804672"/>
+          </a:xfrm>
+          <a:prstGeom prst="rect">
+            <a:avLst/>
+          </a:prstGeom>
+          <a:noFill/>
+          <a:ln w="0">
+            <a:noFill/>
+            <a:prstDash val="solid"/>
+          </a:ln>
+        </p:spPr>
+        <p:txBody>
+          <a:bodyPr/>
+          <a:lstStyle/>
+          <a:p>
+            <a:pPr algn="l">
+              <a:defRPr sz="1013" b="0">
                 <a:solidFill>
                   <a:srgbClr val="17324D"/>
                 </a:solidFill>
-                <a:latin typeface="Aptos" panose="020B0004020202020204" pitchFamily="34" charset="0"/>
+                <a:latin typeface="Aptos"/>
+                <a:ea typeface="Aptos"/>
+                <a:cs typeface="Aptos"/>
+              </a:defRPr>
+            </a:pPr>
+            <a:r>
+              <a:rPr sz="1100" b="1" dirty="0">
+                <a:solidFill>
+                  <a:srgbClr val="0B1F45"/>
+                </a:solidFill>
+                <a:latin typeface="Aptos"/>
               </a:rPr>
               <a:t>MVP hardening</a:t>
             </a:r>
           </a:p>
           <a:p>
-            <a:endParaRPr lang="en-US" sz="1080">
-              <a:solidFill>
-                <a:srgbClr val="17324D"/>
-              </a:solidFill>
-              <a:latin typeface="Aptos" panose="020B0004020202020204" pitchFamily="34" charset="0"/>
-            </a:endParaRPr>
-          </a:p>
-          <a:p>
-            <a:r>
-              <a:rPr lang="en-US" sz="1080">
+            <a:r>
+              <a:rPr sz="1100" b="0" dirty="0">
                 <a:solidFill>
                   <a:srgbClr val="17324D"/>
                 </a:solidFill>
-                <a:latin typeface="Aptos" panose="020B0004020202020204" pitchFamily="34" charset="0"/>
-              </a:rPr>
-              <a:t>Azure, Entra ID, audit, GitHub CI/CD, SDLC.</a:t>
-            </a:r>
-          </a:p>
-        </p:txBody>
-      </p:sp>
-      <p:sp>
-        <p:nvSpPr>
-          <p:cNvPr id="66" name="Oval 65">
-            <a:extLst>
-              <a:ext uri="{FF2B5EF4-FFF2-40B4-BE49-F238E27FC236}">
-                <a16:creationId xmlns:a16="http://schemas.microsoft.com/office/drawing/2014/main" id="{3FA5DFD7-B001-A566-0203-2F1DFA621E9D}"/>
-              </a:ext>
-            </a:extLst>
-          </p:cNvPr>
-          <p:cNvSpPr/>
-          <p:nvPr/>
-        </p:nvSpPr>
-        <p:spPr>
-          <a:xfrm>
-            <a:off x="7143750" y="2863850"/>
-            <a:ext cx="457200" cy="457200"/>
-          </a:xfrm>
-          <a:prstGeom prst="ellipse">
-            <a:avLst/>
-          </a:prstGeom>
-          <a:solidFill>
-            <a:srgbClr val="1769E0"/>
-          </a:solidFill>
-          <a:ln w="19050">
-            <a:noFill/>
-            <a:prstDash val="solid"/>
-          </a:ln>
-          <a:effectLst/>
-          <a:extLst>
-            <a:ext uri="{91240B29-F687-4F45-9708-019B960494DF}">
-              <a14:hiddenLine xmlns:a14="http://schemas.microsoft.com/office/drawing/2010/main" w="19050">
-                <a:solidFill>
-                  <a:schemeClr val="accent1">
-                    <a:shade val="15000"/>
-                  </a:schemeClr>
-                </a:solidFill>
-                <a:prstDash val="solid"/>
-              </a14:hiddenLine>
-            </a:ext>
-          </a:extLst>
-        </p:spPr>
-        <p:style>
-          <a:lnRef idx="2">
-            <a:schemeClr val="accent1">
-              <a:shade val="15000"/>
-            </a:schemeClr>
-          </a:lnRef>
-          <a:fillRef idx="1">
-            <a:schemeClr val="accent1"/>
-          </a:fillRef>
-          <a:effectRef idx="0">
-            <a:schemeClr val="accent1"/>
-          </a:effectRef>
-          <a:fontRef idx="minor">
-            <a:schemeClr val="lt1"/>
-          </a:fontRef>
-        </p:style>
-        <p:txBody>
-          <a:bodyPr rtlCol="0" anchor="ctr"/>
-          <a:lstStyle/>
-          <a:p>
-            <a:pPr algn="ctr"/>
-            <a:endParaRPr lang="en-US"/>
-          </a:p>
-        </p:txBody>
-      </p:sp>
-      <p:sp>
-        <p:nvSpPr>
-          <p:cNvPr id="67" name="TextBox 66">
-            <a:extLst>
-              <a:ext uri="{FF2B5EF4-FFF2-40B4-BE49-F238E27FC236}">
-                <a16:creationId xmlns:a16="http://schemas.microsoft.com/office/drawing/2014/main" id="{49E399E2-2852-0235-FEF2-F992B0EEFC61}"/>
-              </a:ext>
-            </a:extLst>
-          </p:cNvPr>
-          <p:cNvSpPr txBox="1"/>
-          <p:nvPr/>
-        </p:nvSpPr>
-        <p:spPr>
-          <a:xfrm>
-            <a:off x="7143750" y="2984500"/>
-            <a:ext cx="457200" cy="276999"/>
-          </a:xfrm>
-          <a:prstGeom prst="rect">
-            <a:avLst/>
-          </a:prstGeom>
-          <a:noFill/>
-        </p:spPr>
-        <p:txBody>
-          <a:bodyPr vert="horz" wrap="square" lIns="0" tIns="0" rIns="0" bIns="0" rtlCol="0">
-            <a:noAutofit/>
-          </a:bodyPr>
-          <a:lstStyle/>
-          <a:p>
-            <a:pPr algn="ctr"/>
-            <a:r>
-              <a:rPr lang="en-US" sz="1200" b="1">
-                <a:solidFill>
-                  <a:srgbClr val="FFFFFF"/>
-                </a:solidFill>
-                <a:latin typeface="Aptos" panose="020B0004020202020204" pitchFamily="34" charset="0"/>
-              </a:rPr>
-              <a:t>3</a:t>
-            </a:r>
-          </a:p>
-        </p:txBody>
-      </p:sp>
-      <p:sp>
-        <p:nvSpPr>
-          <p:cNvPr id="68" name="Rectangle: Rounded Corners 67">
-            <a:extLst>
-              <a:ext uri="{FF2B5EF4-FFF2-40B4-BE49-F238E27FC236}">
-                <a16:creationId xmlns:a16="http://schemas.microsoft.com/office/drawing/2014/main" id="{F67EE78A-494D-6180-9DAD-873C0AB44AEE}"/>
-              </a:ext>
-            </a:extLst>
-          </p:cNvPr>
-          <p:cNvSpPr/>
-          <p:nvPr/>
-        </p:nvSpPr>
-        <p:spPr>
-          <a:xfrm>
-            <a:off x="6381750" y="3860800"/>
-            <a:ext cx="2247900" cy="1549400"/>
+                <a:latin typeface="Aptos"/>
+              </a:rPr>
+              <a:t>Azure, </a:t>
+            </a:r>
+            <a:r>
+              <a:rPr sz="1100" b="0" dirty="0" err="1">
+                <a:solidFill>
+                  <a:srgbClr val="17324D"/>
+                </a:solidFill>
+                <a:latin typeface="Aptos"/>
+              </a:rPr>
+              <a:t>Entra</a:t>
+            </a:r>
+            <a:r>
+              <a:rPr sz="1100" b="0" dirty="0">
+                <a:solidFill>
+                  <a:srgbClr val="17324D"/>
+                </a:solidFill>
+                <a:latin typeface="Aptos"/>
+              </a:rPr>
+              <a:t> ID, audit, GitHub CI/CD, SDLC.</a:t>
+            </a:r>
+          </a:p>
+        </p:txBody>
+      </p:sp>
+      <p:sp>
+        <p:nvSpPr>
+          <p:cNvPr id="410" name="S9_410">
+            <a:extLst>
+              <a:ext uri="{FF2B5EF4-FFF2-40B4-BE49-F238E27FC236}">
+                <a16:creationId xmlns:a16="http://schemas.microsoft.com/office/drawing/2014/main" id="{2CACBDF1-8DA4-43D1-8F5B-C4EF6F7D9012}"/>
+              </a:ext>
+            </a:extLst>
+          </p:cNvPr>
+          <p:cNvSpPr>
+            <a:spLocks noGrp="1"/>
+          </p:cNvSpPr>
+          <p:nvPr/>
+        </p:nvSpPr>
+        <p:spPr>
+          <a:xfrm>
+            <a:off x="6334963" y="3337560"/>
+            <a:ext cx="2272284" cy="1481328"/>
           </a:xfrm>
           <a:prstGeom prst="roundRect">
-            <a:avLst/>
+            <a:avLst>
+              <a:gd name="adj" fmla="val 8824"/>
+            </a:avLst>
           </a:prstGeom>
           <a:solidFill>
             <a:srgbClr val="EAF3FF"/>
@@ -23896,192 +24025,247 @@
             <a:solidFill>
               <a:srgbClr val="B9D7FF"/>
             </a:solidFill>
-          </a:ln>
-        </p:spPr>
-        <p:style>
-          <a:lnRef idx="2">
-            <a:schemeClr val="accent1">
-              <a:shade val="15000"/>
-            </a:schemeClr>
-          </a:lnRef>
-          <a:fillRef idx="1">
-            <a:schemeClr val="accent1"/>
-          </a:fillRef>
-          <a:effectRef idx="0">
-            <a:schemeClr val="accent1"/>
-          </a:effectRef>
-          <a:fontRef idx="minor">
-            <a:schemeClr val="lt1"/>
-          </a:fontRef>
-        </p:style>
-        <p:txBody>
-          <a:bodyPr rtlCol="0" anchor="ctr"/>
-          <a:lstStyle/>
-          <a:p>
-            <a:pPr algn="ctr"/>
-            <a:endParaRPr lang="en-US"/>
-          </a:p>
-        </p:txBody>
-      </p:sp>
-      <p:sp>
-        <p:nvSpPr>
-          <p:cNvPr id="69" name="Rectangle 68">
-            <a:extLst>
-              <a:ext uri="{FF2B5EF4-FFF2-40B4-BE49-F238E27FC236}">
-                <a16:creationId xmlns:a16="http://schemas.microsoft.com/office/drawing/2014/main" id="{69EFAB0D-6277-279D-29D1-B910DCF91B54}"/>
-              </a:ext>
-            </a:extLst>
-          </p:cNvPr>
-          <p:cNvSpPr/>
-          <p:nvPr/>
-        </p:nvSpPr>
-        <p:spPr>
-          <a:xfrm>
-            <a:off x="6381750" y="3860800"/>
-            <a:ext cx="57150" cy="1549400"/>
-          </a:xfrm>
-          <a:prstGeom prst="rect">
+            <a:prstDash val="solid"/>
+          </a:ln>
+        </p:spPr>
+        <p:txBody>
+          <a:bodyPr/>
+          <a:lstStyle/>
+          <a:p>
+            <a:endParaRPr/>
+          </a:p>
+        </p:txBody>
+      </p:sp>
+      <p:sp>
+        <p:nvSpPr>
+          <p:cNvPr id="411" name="S9_411">
+            <a:extLst>
+              <a:ext uri="{FF2B5EF4-FFF2-40B4-BE49-F238E27FC236}">
+                <a16:creationId xmlns:a16="http://schemas.microsoft.com/office/drawing/2014/main" id="{5B0D52DE-79C5-4F6A-A294-488D692E874D}"/>
+              </a:ext>
+            </a:extLst>
+          </p:cNvPr>
+          <p:cNvSpPr>
+            <a:spLocks noGrp="1"/>
+          </p:cNvSpPr>
+          <p:nvPr/>
+        </p:nvSpPr>
+        <p:spPr>
+          <a:xfrm>
+            <a:off x="6487668" y="3489350"/>
+            <a:ext cx="323850" cy="323850"/>
+          </a:xfrm>
+          <a:prstGeom prst="ellipse">
             <a:avLst/>
           </a:prstGeom>
           <a:solidFill>
-            <a:srgbClr val="1769E0"/>
+            <a:srgbClr val="0B1F45"/>
           </a:solidFill>
-          <a:ln w="19050">
+          <a:ln w="9525">
+            <a:solidFill>
+              <a:srgbClr val="0B1F45"/>
+            </a:solidFill>
+            <a:prstDash val="solid"/>
+          </a:ln>
+        </p:spPr>
+        <p:txBody>
+          <a:bodyPr/>
+          <a:lstStyle/>
+          <a:p>
+            <a:endParaRPr/>
+          </a:p>
+        </p:txBody>
+      </p:sp>
+      <p:sp>
+        <p:nvSpPr>
+          <p:cNvPr id="412" name="S9_412">
+            <a:extLst>
+              <a:ext uri="{FF2B5EF4-FFF2-40B4-BE49-F238E27FC236}">
+                <a16:creationId xmlns:a16="http://schemas.microsoft.com/office/drawing/2014/main" id="{8777E434-01E7-48A4-B11F-BAEC15A3DCCC}"/>
+              </a:ext>
+            </a:extLst>
+          </p:cNvPr>
+          <p:cNvSpPr>
+            <a:spLocks noGrp="1"/>
+          </p:cNvSpPr>
+          <p:nvPr/>
+        </p:nvSpPr>
+        <p:spPr>
+          <a:xfrm>
+            <a:off x="6487668" y="3546957"/>
+            <a:ext cx="323850" cy="171450"/>
+          </a:xfrm>
+          <a:prstGeom prst="rect">
+            <a:avLst/>
+          </a:prstGeom>
+          <a:noFill/>
+          <a:ln w="0">
             <a:noFill/>
             <a:prstDash val="solid"/>
           </a:ln>
-          <a:effectLst/>
-          <a:extLst>
-            <a:ext uri="{91240B29-F687-4F45-9708-019B960494DF}">
-              <a14:hiddenLine xmlns:a14="http://schemas.microsoft.com/office/drawing/2010/main" w="19050">
-                <a:solidFill>
-                  <a:schemeClr val="accent1">
-                    <a:shade val="15000"/>
-                  </a:schemeClr>
-                </a:solidFill>
-                <a:prstDash val="solid"/>
-              </a14:hiddenLine>
-            </a:ext>
-          </a:extLst>
-        </p:spPr>
-        <p:style>
-          <a:lnRef idx="2">
-            <a:schemeClr val="accent1">
-              <a:shade val="15000"/>
-            </a:schemeClr>
-          </a:lnRef>
-          <a:fillRef idx="1">
-            <a:schemeClr val="accent1"/>
-          </a:fillRef>
-          <a:effectRef idx="0">
-            <a:schemeClr val="accent1"/>
-          </a:effectRef>
-          <a:fontRef idx="minor">
-            <a:schemeClr val="lt1"/>
-          </a:fontRef>
-        </p:style>
-        <p:txBody>
-          <a:bodyPr rtlCol="0" anchor="ctr"/>
-          <a:lstStyle/>
-          <a:p>
-            <a:pPr algn="ctr"/>
-            <a:endParaRPr lang="en-US"/>
-          </a:p>
-        </p:txBody>
-      </p:sp>
-      <p:sp>
-        <p:nvSpPr>
-          <p:cNvPr id="70" name="TextBox 69">
-            <a:extLst>
-              <a:ext uri="{FF2B5EF4-FFF2-40B4-BE49-F238E27FC236}">
-                <a16:creationId xmlns:a16="http://schemas.microsoft.com/office/drawing/2014/main" id="{8D0BA442-C7DA-69B8-5EBF-5AA1F697118E}"/>
-              </a:ext>
-            </a:extLst>
-          </p:cNvPr>
-          <p:cNvSpPr txBox="1"/>
-          <p:nvPr/>
-        </p:nvSpPr>
-        <p:spPr>
-          <a:xfrm>
-            <a:off x="6661150" y="4089400"/>
-            <a:ext cx="1689100" cy="276999"/>
-          </a:xfrm>
-          <a:prstGeom prst="rect">
-            <a:avLst/>
-          </a:prstGeom>
-          <a:noFill/>
-        </p:spPr>
-        <p:txBody>
-          <a:bodyPr vert="horz" wrap="square" lIns="0" tIns="0" rIns="0" bIns="0" rtlCol="0">
-            <a:noAutofit/>
-          </a:bodyPr>
-          <a:lstStyle/>
-          <a:p>
-            <a:r>
-              <a:rPr lang="en-US" sz="1450" b="1">
+        </p:spPr>
+        <p:txBody>
+          <a:bodyPr/>
+          <a:lstStyle/>
+          <a:p>
+            <a:pPr algn="ctr">
+              <a:defRPr sz="1050" b="1">
+                <a:solidFill>
+                  <a:srgbClr val="FFFFFF"/>
+                </a:solidFill>
+                <a:latin typeface="Aptos"/>
+                <a:ea typeface="Aptos"/>
+                <a:cs typeface="Aptos"/>
+              </a:defRPr>
+            </a:pPr>
+            <a:r>
+              <a:rPr sz="1050" b="1">
+                <a:solidFill>
+                  <a:srgbClr val="FFFFFF"/>
+                </a:solidFill>
+                <a:latin typeface="Aptos"/>
+                <a:ea typeface="Aptos"/>
+                <a:cs typeface="Aptos"/>
+              </a:rPr>
+              <a:t>3</a:t>
+            </a:r>
+          </a:p>
+        </p:txBody>
+      </p:sp>
+      <p:sp>
+        <p:nvSpPr>
+          <p:cNvPr id="413" name="S9_413">
+            <a:extLst>
+              <a:ext uri="{FF2B5EF4-FFF2-40B4-BE49-F238E27FC236}">
+                <a16:creationId xmlns:a16="http://schemas.microsoft.com/office/drawing/2014/main" id="{A5A0387E-2857-4F24-99D0-66D3CAB56A98}"/>
+              </a:ext>
+            </a:extLst>
+          </p:cNvPr>
+          <p:cNvSpPr>
+            <a:spLocks noGrp="1"/>
+          </p:cNvSpPr>
+          <p:nvPr/>
+        </p:nvSpPr>
+        <p:spPr>
+          <a:xfrm>
+            <a:off x="6869963" y="3473779"/>
+            <a:ext cx="1613001" cy="512064"/>
+          </a:xfrm>
+          <a:prstGeom prst="rect">
+            <a:avLst/>
+          </a:prstGeom>
+          <a:noFill/>
+          <a:ln w="0">
+            <a:noFill/>
+            <a:prstDash val="solid"/>
+          </a:ln>
+        </p:spPr>
+        <p:txBody>
+          <a:bodyPr/>
+          <a:lstStyle/>
+          <a:p>
+            <a:pPr algn="l">
+              <a:defRPr sz="1200" b="1">
                 <a:solidFill>
                   <a:srgbClr val="0B1F45"/>
                 </a:solidFill>
-                <a:latin typeface="Aptos" panose="020B0004020202020204" pitchFamily="34" charset="0"/>
-              </a:rPr>
-              <a:t>3-5 months</a:t>
-            </a:r>
-          </a:p>
-        </p:txBody>
-      </p:sp>
-      <p:sp>
-        <p:nvSpPr>
-          <p:cNvPr id="71" name="TextBox 70">
-            <a:extLst>
-              <a:ext uri="{FF2B5EF4-FFF2-40B4-BE49-F238E27FC236}">
-                <a16:creationId xmlns:a16="http://schemas.microsoft.com/office/drawing/2014/main" id="{B2D0CF48-41EA-1D5B-73FC-507F1B284BC2}"/>
-              </a:ext>
-            </a:extLst>
-          </p:cNvPr>
-          <p:cNvSpPr txBox="1"/>
-          <p:nvPr/>
-        </p:nvSpPr>
-        <p:spPr>
-          <a:xfrm>
-            <a:off x="6661150" y="4546600"/>
-            <a:ext cx="1689100" cy="276999"/>
-          </a:xfrm>
-          <a:prstGeom prst="rect">
-            <a:avLst/>
-          </a:prstGeom>
-          <a:noFill/>
-        </p:spPr>
-        <p:txBody>
-          <a:bodyPr vert="horz" wrap="square" lIns="0" tIns="0" rIns="0" bIns="0" rtlCol="0">
-            <a:noAutofit/>
-          </a:bodyPr>
-          <a:lstStyle/>
-          <a:p>
-            <a:r>
-              <a:rPr lang="en-US" sz="1080">
+                <a:latin typeface="Aptos"/>
+                <a:ea typeface="Aptos"/>
+                <a:cs typeface="Aptos"/>
+              </a:defRPr>
+            </a:pPr>
+            <a:r>
+              <a:rPr sz="1100" b="1" dirty="0">
+                <a:solidFill>
+                  <a:srgbClr val="0B1F45"/>
+                </a:solidFill>
+                <a:latin typeface="Aptos"/>
+                <a:ea typeface="Aptos"/>
+                <a:cs typeface="Aptos"/>
+              </a:rPr>
+              <a:t>3–5 months</a:t>
+            </a:r>
+          </a:p>
+          <a:p>
+            <a:pPr>
+              <a:spcBef>
+                <a:spcPts val="100"/>
+              </a:spcBef>
+              <a:spcAft>
+                <a:spcPts val="0"/>
+              </a:spcAft>
+            </a:pPr>
+            <a:r>
+              <a:rPr sz="1100" b="1" dirty="0">
+                <a:solidFill>
+                  <a:srgbClr val="1769E0"/>
+                </a:solidFill>
+                <a:latin typeface="Aptos"/>
+              </a:rPr>
+              <a:t>Oct–Nov 2026</a:t>
+            </a:r>
+          </a:p>
+        </p:txBody>
+      </p:sp>
+      <p:sp>
+        <p:nvSpPr>
+          <p:cNvPr id="414" name="S9_414">
+            <a:extLst>
+              <a:ext uri="{FF2B5EF4-FFF2-40B4-BE49-F238E27FC236}">
+                <a16:creationId xmlns:a16="http://schemas.microsoft.com/office/drawing/2014/main" id="{391BB3CB-DEB7-417E-B3A0-A51536B66302}"/>
+              </a:ext>
+            </a:extLst>
+          </p:cNvPr>
+          <p:cNvSpPr>
+            <a:spLocks noGrp="1"/>
+          </p:cNvSpPr>
+          <p:nvPr/>
+        </p:nvSpPr>
+        <p:spPr>
+          <a:xfrm>
+            <a:off x="6506870" y="3922776"/>
+            <a:ext cx="1928469" cy="804672"/>
+          </a:xfrm>
+          <a:prstGeom prst="rect">
+            <a:avLst/>
+          </a:prstGeom>
+          <a:noFill/>
+          <a:ln w="0">
+            <a:noFill/>
+            <a:prstDash val="solid"/>
+          </a:ln>
+        </p:spPr>
+        <p:txBody>
+          <a:bodyPr/>
+          <a:lstStyle/>
+          <a:p>
+            <a:pPr algn="l">
+              <a:defRPr sz="1013" b="0">
                 <a:solidFill>
                   <a:srgbClr val="17324D"/>
                 </a:solidFill>
-                <a:latin typeface="Aptos" panose="020B0004020202020204" pitchFamily="34" charset="0"/>
+                <a:latin typeface="Aptos"/>
+                <a:ea typeface="Aptos"/>
+                <a:cs typeface="Aptos"/>
+              </a:defRPr>
+            </a:pPr>
+            <a:r>
+              <a:rPr sz="1100" b="1" dirty="0">
+                <a:solidFill>
+                  <a:srgbClr val="0B1F45"/>
+                </a:solidFill>
+                <a:latin typeface="Aptos"/>
               </a:rPr>
               <a:t>Pilot</a:t>
             </a:r>
           </a:p>
           <a:p>
-            <a:endParaRPr lang="en-US" sz="1080">
-              <a:solidFill>
-                <a:srgbClr val="17324D"/>
-              </a:solidFill>
-              <a:latin typeface="Aptos" panose="020B0004020202020204" pitchFamily="34" charset="0"/>
-            </a:endParaRPr>
-          </a:p>
-          <a:p>
-            <a:r>
-              <a:rPr lang="en-US" sz="1080">
+            <a:r>
+              <a:rPr sz="1100" b="0" dirty="0">
                 <a:solidFill>
                   <a:srgbClr val="17324D"/>
                 </a:solidFill>
-                <a:latin typeface="Aptos" panose="020B0004020202020204" pitchFamily="34" charset="0"/>
+                <a:latin typeface="Aptos"/>
               </a:rPr>
               <a:t>One or two LSPs, manual exception flow, reporting.</a:t>
             </a:r>
@@ -24090,130 +24274,27 @@
       </p:sp>
       <p:sp>
         <p:nvSpPr>
-          <p:cNvPr id="72" name="Oval 71">
-            <a:extLst>
-              <a:ext uri="{FF2B5EF4-FFF2-40B4-BE49-F238E27FC236}">
-                <a16:creationId xmlns:a16="http://schemas.microsoft.com/office/drawing/2014/main" id="{8D539FF8-B713-854C-FBD2-9622EBF5E7AA}"/>
-              </a:ext>
-            </a:extLst>
-          </p:cNvPr>
-          <p:cNvSpPr/>
-          <p:nvPr/>
-        </p:nvSpPr>
-        <p:spPr>
-          <a:xfrm>
-            <a:off x="9925050" y="2863850"/>
-            <a:ext cx="457200" cy="457200"/>
-          </a:xfrm>
-          <a:prstGeom prst="ellipse">
-            <a:avLst/>
-          </a:prstGeom>
-          <a:solidFill>
-            <a:srgbClr val="1769E0"/>
-          </a:solidFill>
-          <a:ln w="19050">
-            <a:noFill/>
-            <a:prstDash val="solid"/>
-          </a:ln>
-          <a:effectLst/>
-          <a:extLst>
-            <a:ext uri="{91240B29-F687-4F45-9708-019B960494DF}">
-              <a14:hiddenLine xmlns:a14="http://schemas.microsoft.com/office/drawing/2010/main" w="19050">
-                <a:solidFill>
-                  <a:schemeClr val="accent1">
-                    <a:shade val="15000"/>
-                  </a:schemeClr>
-                </a:solidFill>
-                <a:prstDash val="solid"/>
-              </a14:hiddenLine>
-            </a:ext>
-          </a:extLst>
-        </p:spPr>
-        <p:style>
-          <a:lnRef idx="2">
-            <a:schemeClr val="accent1">
-              <a:shade val="15000"/>
-            </a:schemeClr>
-          </a:lnRef>
-          <a:fillRef idx="1">
-            <a:schemeClr val="accent1"/>
-          </a:fillRef>
-          <a:effectRef idx="0">
-            <a:schemeClr val="accent1"/>
-          </a:effectRef>
-          <a:fontRef idx="minor">
-            <a:schemeClr val="lt1"/>
-          </a:fontRef>
-        </p:style>
-        <p:txBody>
-          <a:bodyPr rtlCol="0" anchor="ctr"/>
-          <a:lstStyle/>
-          <a:p>
-            <a:pPr algn="ctr"/>
-            <a:endParaRPr lang="en-US"/>
-          </a:p>
-        </p:txBody>
-      </p:sp>
-      <p:sp>
-        <p:nvSpPr>
-          <p:cNvPr id="73" name="TextBox 72">
-            <a:extLst>
-              <a:ext uri="{FF2B5EF4-FFF2-40B4-BE49-F238E27FC236}">
-                <a16:creationId xmlns:a16="http://schemas.microsoft.com/office/drawing/2014/main" id="{E35BE8AF-44E0-D85E-03A6-59686831C314}"/>
-              </a:ext>
-            </a:extLst>
-          </p:cNvPr>
-          <p:cNvSpPr txBox="1"/>
-          <p:nvPr/>
-        </p:nvSpPr>
-        <p:spPr>
-          <a:xfrm>
-            <a:off x="9925050" y="2984500"/>
-            <a:ext cx="457200" cy="276999"/>
-          </a:xfrm>
-          <a:prstGeom prst="rect">
-            <a:avLst/>
-          </a:prstGeom>
-          <a:noFill/>
-        </p:spPr>
-        <p:txBody>
-          <a:bodyPr vert="horz" wrap="square" lIns="0" tIns="0" rIns="0" bIns="0" rtlCol="0">
-            <a:noAutofit/>
-          </a:bodyPr>
-          <a:lstStyle/>
-          <a:p>
-            <a:pPr algn="ctr"/>
-            <a:r>
-              <a:rPr lang="en-US" sz="1200" b="1">
-                <a:solidFill>
-                  <a:srgbClr val="FFFFFF"/>
-                </a:solidFill>
-                <a:latin typeface="Aptos" panose="020B0004020202020204" pitchFamily="34" charset="0"/>
-              </a:rPr>
-              <a:t>4</a:t>
-            </a:r>
-          </a:p>
-        </p:txBody>
-      </p:sp>
-      <p:sp>
-        <p:nvSpPr>
-          <p:cNvPr id="74" name="Rectangle: Rounded Corners 73">
-            <a:extLst>
-              <a:ext uri="{FF2B5EF4-FFF2-40B4-BE49-F238E27FC236}">
-                <a16:creationId xmlns:a16="http://schemas.microsoft.com/office/drawing/2014/main" id="{B1CCFDE2-5A67-BBA6-3492-3A4F261DF475}"/>
-              </a:ext>
-            </a:extLst>
-          </p:cNvPr>
-          <p:cNvSpPr/>
-          <p:nvPr/>
-        </p:nvSpPr>
-        <p:spPr>
-          <a:xfrm>
-            <a:off x="9163050" y="3860800"/>
-            <a:ext cx="2247900" cy="1549400"/>
+          <p:cNvPr id="415" name="S9_415">
+            <a:extLst>
+              <a:ext uri="{FF2B5EF4-FFF2-40B4-BE49-F238E27FC236}">
+                <a16:creationId xmlns:a16="http://schemas.microsoft.com/office/drawing/2014/main" id="{55427757-C608-4EDE-87DF-572039BD3F21}"/>
+              </a:ext>
+            </a:extLst>
+          </p:cNvPr>
+          <p:cNvSpPr>
+            <a:spLocks noGrp="1"/>
+          </p:cNvSpPr>
+          <p:nvPr/>
+        </p:nvSpPr>
+        <p:spPr>
+          <a:xfrm>
+            <a:off x="9064447" y="3337560"/>
+            <a:ext cx="2464534" cy="1481328"/>
           </a:xfrm>
           <a:prstGeom prst="roundRect">
-            <a:avLst/>
+            <a:avLst>
+              <a:gd name="adj" fmla="val 8824"/>
+            </a:avLst>
           </a:prstGeom>
           <a:solidFill>
             <a:srgbClr val="EAF3FF"/>
@@ -24222,194 +24303,425 @@
             <a:solidFill>
               <a:srgbClr val="B9D7FF"/>
             </a:solidFill>
-          </a:ln>
-        </p:spPr>
-        <p:style>
-          <a:lnRef idx="2">
-            <a:schemeClr val="accent1">
-              <a:shade val="15000"/>
-            </a:schemeClr>
-          </a:lnRef>
-          <a:fillRef idx="1">
-            <a:schemeClr val="accent1"/>
-          </a:fillRef>
-          <a:effectRef idx="0">
-            <a:schemeClr val="accent1"/>
-          </a:effectRef>
-          <a:fontRef idx="minor">
-            <a:schemeClr val="lt1"/>
-          </a:fontRef>
-        </p:style>
-        <p:txBody>
-          <a:bodyPr rtlCol="0" anchor="ctr"/>
-          <a:lstStyle/>
-          <a:p>
-            <a:pPr algn="ctr"/>
-            <a:endParaRPr lang="en-US"/>
-          </a:p>
-        </p:txBody>
-      </p:sp>
-      <p:sp>
-        <p:nvSpPr>
-          <p:cNvPr id="75" name="Rectangle 74">
-            <a:extLst>
-              <a:ext uri="{FF2B5EF4-FFF2-40B4-BE49-F238E27FC236}">
-                <a16:creationId xmlns:a16="http://schemas.microsoft.com/office/drawing/2014/main" id="{4597023A-949D-7238-DD57-77686B8425D7}"/>
-              </a:ext>
-            </a:extLst>
-          </p:cNvPr>
-          <p:cNvSpPr/>
-          <p:nvPr/>
-        </p:nvSpPr>
-        <p:spPr>
-          <a:xfrm>
-            <a:off x="9163050" y="3860800"/>
-            <a:ext cx="57150" cy="1549400"/>
-          </a:xfrm>
-          <a:prstGeom prst="rect">
+            <a:prstDash val="solid"/>
+          </a:ln>
+        </p:spPr>
+        <p:txBody>
+          <a:bodyPr/>
+          <a:lstStyle/>
+          <a:p>
+            <a:endParaRPr/>
+          </a:p>
+        </p:txBody>
+      </p:sp>
+      <p:sp>
+        <p:nvSpPr>
+          <p:cNvPr id="416" name="S9_416">
+            <a:extLst>
+              <a:ext uri="{FF2B5EF4-FFF2-40B4-BE49-F238E27FC236}">
+                <a16:creationId xmlns:a16="http://schemas.microsoft.com/office/drawing/2014/main" id="{92855D96-CDEC-4559-A422-07A89EEB746F}"/>
+              </a:ext>
+            </a:extLst>
+          </p:cNvPr>
+          <p:cNvSpPr>
+            <a:spLocks noGrp="1"/>
+          </p:cNvSpPr>
+          <p:nvPr/>
+        </p:nvSpPr>
+        <p:spPr>
+          <a:xfrm>
+            <a:off x="9217152" y="3489350"/>
+            <a:ext cx="323850" cy="323850"/>
+          </a:xfrm>
+          <a:prstGeom prst="ellipse">
+            <a:avLst/>
+          </a:prstGeom>
+          <a:solidFill>
+            <a:srgbClr val="0B1F45"/>
+          </a:solidFill>
+          <a:ln w="9525">
+            <a:solidFill>
+              <a:srgbClr val="0B1F45"/>
+            </a:solidFill>
+            <a:prstDash val="solid"/>
+          </a:ln>
+        </p:spPr>
+        <p:txBody>
+          <a:bodyPr/>
+          <a:lstStyle/>
+          <a:p>
+            <a:endParaRPr/>
+          </a:p>
+        </p:txBody>
+      </p:sp>
+      <p:sp>
+        <p:nvSpPr>
+          <p:cNvPr id="417" name="S9_417">
+            <a:extLst>
+              <a:ext uri="{FF2B5EF4-FFF2-40B4-BE49-F238E27FC236}">
+                <a16:creationId xmlns:a16="http://schemas.microsoft.com/office/drawing/2014/main" id="{DC372C6B-2299-420A-B8D0-779AFCA61E8C}"/>
+              </a:ext>
+            </a:extLst>
+          </p:cNvPr>
+          <p:cNvSpPr>
+            <a:spLocks noGrp="1"/>
+          </p:cNvSpPr>
+          <p:nvPr/>
+        </p:nvSpPr>
+        <p:spPr>
+          <a:xfrm>
+            <a:off x="9217152" y="3546957"/>
+            <a:ext cx="323850" cy="171450"/>
+          </a:xfrm>
+          <a:prstGeom prst="rect">
+            <a:avLst/>
+          </a:prstGeom>
+          <a:noFill/>
+          <a:ln w="0">
+            <a:noFill/>
+            <a:prstDash val="solid"/>
+          </a:ln>
+        </p:spPr>
+        <p:txBody>
+          <a:bodyPr/>
+          <a:lstStyle/>
+          <a:p>
+            <a:pPr algn="ctr">
+              <a:defRPr sz="1050" b="1">
+                <a:solidFill>
+                  <a:srgbClr val="FFFFFF"/>
+                </a:solidFill>
+                <a:latin typeface="Aptos"/>
+                <a:ea typeface="Aptos"/>
+                <a:cs typeface="Aptos"/>
+              </a:defRPr>
+            </a:pPr>
+            <a:r>
+              <a:rPr sz="1050" b="1">
+                <a:solidFill>
+                  <a:srgbClr val="FFFFFF"/>
+                </a:solidFill>
+                <a:latin typeface="Aptos"/>
+                <a:ea typeface="Aptos"/>
+                <a:cs typeface="Aptos"/>
+              </a:rPr>
+              <a:t>4</a:t>
+            </a:r>
+          </a:p>
+        </p:txBody>
+      </p:sp>
+      <p:sp>
+        <p:nvSpPr>
+          <p:cNvPr id="418" name="S9_418">
+            <a:extLst>
+              <a:ext uri="{FF2B5EF4-FFF2-40B4-BE49-F238E27FC236}">
+                <a16:creationId xmlns:a16="http://schemas.microsoft.com/office/drawing/2014/main" id="{D2F10DB2-7389-4CF0-99F2-C89C9E8165F5}"/>
+              </a:ext>
+            </a:extLst>
+          </p:cNvPr>
+          <p:cNvSpPr>
+            <a:spLocks noGrp="1"/>
+          </p:cNvSpPr>
+          <p:nvPr/>
+        </p:nvSpPr>
+        <p:spPr>
+          <a:xfrm>
+            <a:off x="9618421" y="3462375"/>
+            <a:ext cx="1613001" cy="512064"/>
+          </a:xfrm>
+          <a:prstGeom prst="rect">
+            <a:avLst/>
+          </a:prstGeom>
+          <a:noFill/>
+          <a:ln w="0">
+            <a:noFill/>
+            <a:prstDash val="solid"/>
+          </a:ln>
+        </p:spPr>
+        <p:txBody>
+          <a:bodyPr/>
+          <a:lstStyle/>
+          <a:p>
+            <a:pPr algn="l">
+              <a:defRPr sz="1200" b="1">
+                <a:solidFill>
+                  <a:srgbClr val="0B1F45"/>
+                </a:solidFill>
+                <a:latin typeface="Aptos"/>
+                <a:ea typeface="Aptos"/>
+                <a:cs typeface="Aptos"/>
+              </a:defRPr>
+            </a:pPr>
+            <a:r>
+              <a:rPr sz="1100" b="1" dirty="0">
+                <a:solidFill>
+                  <a:srgbClr val="0B1F45"/>
+                </a:solidFill>
+                <a:latin typeface="Aptos"/>
+                <a:ea typeface="Aptos"/>
+                <a:cs typeface="Aptos"/>
+              </a:rPr>
+              <a:t>5–8 months</a:t>
+            </a:r>
+          </a:p>
+          <a:p>
+            <a:pPr>
+              <a:spcBef>
+                <a:spcPts val="100"/>
+              </a:spcBef>
+              <a:spcAft>
+                <a:spcPts val="0"/>
+              </a:spcAft>
+            </a:pPr>
+            <a:r>
+              <a:rPr sz="1100" b="1" dirty="0">
+                <a:solidFill>
+                  <a:srgbClr val="1769E0"/>
+                </a:solidFill>
+                <a:latin typeface="Aptos"/>
+              </a:rPr>
+              <a:t>Dec 2026–Feb 2027</a:t>
+            </a:r>
+          </a:p>
+        </p:txBody>
+      </p:sp>
+      <p:sp>
+        <p:nvSpPr>
+          <p:cNvPr id="419" name="S9_419">
+            <a:extLst>
+              <a:ext uri="{FF2B5EF4-FFF2-40B4-BE49-F238E27FC236}">
+                <a16:creationId xmlns:a16="http://schemas.microsoft.com/office/drawing/2014/main" id="{C016C6E2-DE02-4FC4-B234-BD259BCDF7B0}"/>
+              </a:ext>
+            </a:extLst>
+          </p:cNvPr>
+          <p:cNvSpPr>
+            <a:spLocks noGrp="1"/>
+          </p:cNvSpPr>
+          <p:nvPr/>
+        </p:nvSpPr>
+        <p:spPr>
+          <a:xfrm>
+            <a:off x="9236354" y="3922776"/>
+            <a:ext cx="1928469" cy="804672"/>
+          </a:xfrm>
+          <a:prstGeom prst="rect">
+            <a:avLst/>
+          </a:prstGeom>
+          <a:noFill/>
+          <a:ln w="0">
+            <a:noFill/>
+            <a:prstDash val="solid"/>
+          </a:ln>
+        </p:spPr>
+        <p:txBody>
+          <a:bodyPr/>
+          <a:lstStyle/>
+          <a:p>
+            <a:pPr algn="l">
+              <a:defRPr sz="1013" b="0">
+                <a:solidFill>
+                  <a:srgbClr val="17324D"/>
+                </a:solidFill>
+                <a:latin typeface="Aptos"/>
+                <a:ea typeface="Aptos"/>
+                <a:cs typeface="Aptos"/>
+              </a:defRPr>
+            </a:pPr>
+            <a:r>
+              <a:rPr sz="1100" b="1" dirty="0">
+                <a:solidFill>
+                  <a:srgbClr val="0B1F45"/>
+                </a:solidFill>
+                <a:latin typeface="Aptos"/>
+              </a:rPr>
+              <a:t>Scale readiness</a:t>
+            </a:r>
+          </a:p>
+          <a:p>
+            <a:r>
+              <a:rPr sz="1100" b="0" dirty="0">
+                <a:solidFill>
+                  <a:srgbClr val="17324D"/>
+                </a:solidFill>
+                <a:latin typeface="Aptos"/>
+              </a:rPr>
+              <a:t>Monitoring, DR, performance, Databricks DWH.</a:t>
+            </a:r>
+          </a:p>
+        </p:txBody>
+      </p:sp>
+      <p:sp>
+        <p:nvSpPr>
+          <p:cNvPr id="420" name="S9arr_420">
+            <a:extLst>
+              <a:ext uri="{FF2B5EF4-FFF2-40B4-BE49-F238E27FC236}">
+                <a16:creationId xmlns:a16="http://schemas.microsoft.com/office/drawing/2014/main" id="{AD04E8C3-F453-4CD2-8696-8C128404925E}"/>
+              </a:ext>
+            </a:extLst>
+          </p:cNvPr>
+          <p:cNvSpPr>
+            <a:spLocks noGrp="1"/>
+          </p:cNvSpPr>
+          <p:nvPr/>
+        </p:nvSpPr>
+        <p:spPr>
+          <a:xfrm>
+            <a:off x="3215030" y="3963924"/>
+            <a:ext cx="323850" cy="228600"/>
+          </a:xfrm>
+          <a:prstGeom prst="rightArrow">
             <a:avLst/>
           </a:prstGeom>
           <a:solidFill>
             <a:srgbClr val="1769E0"/>
           </a:solidFill>
-          <a:ln w="19050">
+          <a:ln w="0">
+            <a:solidFill>
+              <a:srgbClr val="1769E0"/>
+            </a:solidFill>
+            <a:prstDash val="solid"/>
+          </a:ln>
+        </p:spPr>
+        <p:txBody>
+          <a:bodyPr/>
+          <a:lstStyle/>
+          <a:p>
+            <a:endParaRPr/>
+          </a:p>
+        </p:txBody>
+      </p:sp>
+      <p:sp>
+        <p:nvSpPr>
+          <p:cNvPr id="421" name="S9arr_421">
+            <a:extLst>
+              <a:ext uri="{FF2B5EF4-FFF2-40B4-BE49-F238E27FC236}">
+                <a16:creationId xmlns:a16="http://schemas.microsoft.com/office/drawing/2014/main" id="{6D26D279-6FAC-4E28-834E-3A6F8D1C5649}"/>
+              </a:ext>
+            </a:extLst>
+          </p:cNvPr>
+          <p:cNvSpPr>
+            <a:spLocks noGrp="1"/>
+          </p:cNvSpPr>
+          <p:nvPr/>
+        </p:nvSpPr>
+        <p:spPr>
+          <a:xfrm>
+            <a:off x="5944514" y="3963924"/>
+            <a:ext cx="323850" cy="228600"/>
+          </a:xfrm>
+          <a:prstGeom prst="rightArrow">
+            <a:avLst/>
+          </a:prstGeom>
+          <a:solidFill>
+            <a:srgbClr val="1769E0"/>
+          </a:solidFill>
+          <a:ln w="0">
+            <a:solidFill>
+              <a:srgbClr val="1769E0"/>
+            </a:solidFill>
+            <a:prstDash val="solid"/>
+          </a:ln>
+        </p:spPr>
+        <p:txBody>
+          <a:bodyPr/>
+          <a:lstStyle/>
+          <a:p>
+            <a:endParaRPr/>
+          </a:p>
+        </p:txBody>
+      </p:sp>
+      <p:sp>
+        <p:nvSpPr>
+          <p:cNvPr id="422" name="S9arr_422">
+            <a:extLst>
+              <a:ext uri="{FF2B5EF4-FFF2-40B4-BE49-F238E27FC236}">
+                <a16:creationId xmlns:a16="http://schemas.microsoft.com/office/drawing/2014/main" id="{BDCB473C-85F9-4C34-B389-7FDCFE3BD683}"/>
+              </a:ext>
+            </a:extLst>
+          </p:cNvPr>
+          <p:cNvSpPr>
+            <a:spLocks noGrp="1"/>
+          </p:cNvSpPr>
+          <p:nvPr/>
+        </p:nvSpPr>
+        <p:spPr>
+          <a:xfrm>
+            <a:off x="8673998" y="3963924"/>
+            <a:ext cx="323850" cy="228600"/>
+          </a:xfrm>
+          <a:prstGeom prst="rightArrow">
+            <a:avLst/>
+          </a:prstGeom>
+          <a:solidFill>
+            <a:srgbClr val="1769E0"/>
+          </a:solidFill>
+          <a:ln w="0">
+            <a:solidFill>
+              <a:srgbClr val="1769E0"/>
+            </a:solidFill>
+            <a:prstDash val="solid"/>
+          </a:ln>
+        </p:spPr>
+        <p:txBody>
+          <a:bodyPr/>
+          <a:lstStyle/>
+          <a:p>
+            <a:endParaRPr/>
+          </a:p>
+        </p:txBody>
+      </p:sp>
+      <p:sp>
+        <p:nvSpPr>
+          <p:cNvPr id="423" name="S9_takeaway">
+            <a:extLst>
+              <a:ext uri="{FF2B5EF4-FFF2-40B4-BE49-F238E27FC236}">
+                <a16:creationId xmlns:a16="http://schemas.microsoft.com/office/drawing/2014/main" id="{EC1319A2-82B0-4D1E-8561-807185C13618}"/>
+              </a:ext>
+            </a:extLst>
+          </p:cNvPr>
+          <p:cNvSpPr>
+            <a:spLocks noGrp="1"/>
+          </p:cNvSpPr>
+          <p:nvPr/>
+        </p:nvSpPr>
+        <p:spPr>
+          <a:xfrm>
+            <a:off x="779864" y="5511910"/>
+            <a:ext cx="9914160" cy="323850"/>
+          </a:xfrm>
+          <a:prstGeom prst="rect">
+            <a:avLst/>
+          </a:prstGeom>
+          <a:noFill/>
+          <a:ln w="0">
             <a:noFill/>
             <a:prstDash val="solid"/>
           </a:ln>
-          <a:effectLst/>
-          <a:extLst>
-            <a:ext uri="{91240B29-F687-4F45-9708-019B960494DF}">
-              <a14:hiddenLine xmlns:a14="http://schemas.microsoft.com/office/drawing/2010/main" w="19050">
-                <a:solidFill>
-                  <a:schemeClr val="accent1">
-                    <a:shade val="15000"/>
-                  </a:schemeClr>
-                </a:solidFill>
-                <a:prstDash val="solid"/>
-              </a14:hiddenLine>
-            </a:ext>
-          </a:extLst>
-        </p:spPr>
-        <p:style>
-          <a:lnRef idx="2">
-            <a:schemeClr val="accent1">
-              <a:shade val="15000"/>
-            </a:schemeClr>
-          </a:lnRef>
-          <a:fillRef idx="1">
-            <a:schemeClr val="accent1"/>
-          </a:fillRef>
-          <a:effectRef idx="0">
-            <a:schemeClr val="accent1"/>
-          </a:effectRef>
-          <a:fontRef idx="minor">
-            <a:schemeClr val="lt1"/>
-          </a:fontRef>
-        </p:style>
-        <p:txBody>
-          <a:bodyPr rtlCol="0" anchor="ctr"/>
-          <a:lstStyle/>
-          <a:p>
-            <a:pPr algn="ctr"/>
-            <a:endParaRPr lang="en-US"/>
-          </a:p>
-        </p:txBody>
-      </p:sp>
-      <p:sp>
-        <p:nvSpPr>
-          <p:cNvPr id="76" name="TextBox 75">
-            <a:extLst>
-              <a:ext uri="{FF2B5EF4-FFF2-40B4-BE49-F238E27FC236}">
-                <a16:creationId xmlns:a16="http://schemas.microsoft.com/office/drawing/2014/main" id="{864F6638-67D1-70ED-EF4A-C265DD504A6C}"/>
-              </a:ext>
-            </a:extLst>
-          </p:cNvPr>
-          <p:cNvSpPr txBox="1"/>
-          <p:nvPr/>
-        </p:nvSpPr>
-        <p:spPr>
-          <a:xfrm>
-            <a:off x="9442450" y="4089400"/>
-            <a:ext cx="1689100" cy="276999"/>
-          </a:xfrm>
-          <a:prstGeom prst="rect">
-            <a:avLst/>
-          </a:prstGeom>
-          <a:noFill/>
-        </p:spPr>
-        <p:txBody>
-          <a:bodyPr vert="horz" wrap="square" lIns="0" tIns="0" rIns="0" bIns="0" rtlCol="0">
-            <a:noAutofit/>
-          </a:bodyPr>
-          <a:lstStyle/>
-          <a:p>
-            <a:r>
-              <a:rPr lang="en-US" sz="1450" b="1">
+        </p:spPr>
+        <p:txBody>
+          <a:bodyPr/>
+          <a:lstStyle/>
+          <a:p>
+            <a:pPr algn="ctr">
+              <a:defRPr sz="1500" b="1">
                 <a:solidFill>
                   <a:srgbClr val="0B1F45"/>
                 </a:solidFill>
-                <a:latin typeface="Aptos" panose="020B0004020202020204" pitchFamily="34" charset="0"/>
-              </a:rPr>
-              <a:t>5-8 months</a:t>
-            </a:r>
-          </a:p>
-        </p:txBody>
-      </p:sp>
-      <p:sp>
-        <p:nvSpPr>
-          <p:cNvPr id="77" name="TextBox 76">
-            <a:extLst>
-              <a:ext uri="{FF2B5EF4-FFF2-40B4-BE49-F238E27FC236}">
-                <a16:creationId xmlns:a16="http://schemas.microsoft.com/office/drawing/2014/main" id="{6A3B9EC2-B708-CD7A-188A-93E5CE16C4D1}"/>
-              </a:ext>
-            </a:extLst>
-          </p:cNvPr>
-          <p:cNvSpPr txBox="1"/>
-          <p:nvPr/>
-        </p:nvSpPr>
-        <p:spPr>
-          <a:xfrm>
-            <a:off x="9442450" y="4546600"/>
-            <a:ext cx="1689100" cy="276999"/>
-          </a:xfrm>
-          <a:prstGeom prst="rect">
-            <a:avLst/>
-          </a:prstGeom>
-          <a:noFill/>
-        </p:spPr>
-        <p:txBody>
-          <a:bodyPr vert="horz" wrap="square" lIns="0" tIns="0" rIns="0" bIns="0" rtlCol="0">
-            <a:noAutofit/>
-          </a:bodyPr>
-          <a:lstStyle/>
-          <a:p>
-            <a:r>
-              <a:rPr lang="en-US" sz="1080">
-                <a:solidFill>
-                  <a:srgbClr val="17324D"/>
-                </a:solidFill>
-                <a:latin typeface="Aptos" panose="020B0004020202020204" pitchFamily="34" charset="0"/>
-              </a:rPr>
-              <a:t>Scale readiness</a:t>
-            </a:r>
-          </a:p>
-          <a:p>
-            <a:endParaRPr lang="en-US" sz="1080">
-              <a:solidFill>
-                <a:srgbClr val="17324D"/>
-              </a:solidFill>
-              <a:latin typeface="Aptos" panose="020B0004020202020204" pitchFamily="34" charset="0"/>
-            </a:endParaRPr>
-          </a:p>
-          <a:p>
-            <a:r>
-              <a:rPr lang="en-US" sz="1080">
-                <a:solidFill>
-                  <a:srgbClr val="17324D"/>
-                </a:solidFill>
-                <a:latin typeface="Aptos" panose="020B0004020202020204" pitchFamily="34" charset="0"/>
-              </a:rPr>
-              <a:t>Monitoring, DR, performance, Databricks DWH.</a:t>
+                <a:latin typeface="Aptos"/>
+                <a:ea typeface="Aptos"/>
+                <a:cs typeface="Aptos"/>
+              </a:defRPr>
+            </a:pPr>
+            <a:r>
+              <a:rPr sz="1500" b="1" dirty="0">
+                <a:solidFill>
+                  <a:srgbClr val="0B1F45"/>
+                </a:solidFill>
+                <a:latin typeface="Aptos"/>
+                <a:ea typeface="Aptos"/>
+                <a:cs typeface="Aptos"/>
+              </a:rPr>
+              <a:t>Production scale is earned gate by gate — proven ownership, security, audit, and clear LSP value, not a demo.</a:t>
             </a:r>
           </a:p>
         </p:txBody>

</xml_diff>